<commit_message>
Updates to week 2 E26
</commit_message>
<xml_diff>
--- a/02 Strategy/OCP.pptx
+++ b/02 Strategy/OCP.pptx
@@ -221,7 +221,7 @@
           <a:p>
             <a:fld id="{8A6E8EB0-8888-4A4E-94F3-14D8E5038AB6}" type="datetimeFigureOut">
               <a:rPr lang="en-US" smtClean="0"/>
-              <a:t>9/3/25</a:t>
+              <a:t>9/2/26</a:t>
             </a:fld>
             <a:endParaRPr lang="en-US"/>
           </a:p>
@@ -3328,7 +3328,7 @@
         <p:spPr>
           <a:xfrm>
             <a:off x="4644008" y="4576479"/>
-            <a:ext cx="4022255" cy="2092881"/>
+            <a:ext cx="4392488" cy="2246769"/>
           </a:xfrm>
           <a:prstGeom prst="rect">
             <a:avLst/>
@@ -3350,258 +3350,202 @@
           </a:effectLst>
         </p:spPr>
         <p:txBody>
-          <a:bodyPr wrap="none" rtlCol="0">
+          <a:bodyPr wrap="square" rtlCol="0">
             <a:spAutoFit/>
           </a:bodyPr>
           <a:lstStyle/>
           <a:p>
             <a:r>
-              <a:rPr lang="da-DK" sz="1300" dirty="0" err="1">
-                <a:latin typeface="Consolas" pitchFamily="49" charset="0"/>
-                <a:cs typeface="Consolas" pitchFamily="49" charset="0"/>
-              </a:rPr>
-              <a:t>void</a:t>
-            </a:r>
-            <a:r>
-              <a:rPr lang="da-DK" sz="1300" dirty="0">
-                <a:latin typeface="Consolas" pitchFamily="49" charset="0"/>
-                <a:cs typeface="Consolas" pitchFamily="49" charset="0"/>
-              </a:rPr>
-              <a:t> </a:t>
-            </a:r>
-            <a:r>
-              <a:rPr lang="da-DK" sz="1300" dirty="0" err="1">
-                <a:latin typeface="Consolas" pitchFamily="49" charset="0"/>
-                <a:cs typeface="Consolas" pitchFamily="49" charset="0"/>
-              </a:rPr>
-              <a:t>YeOlePrinterDriver</a:t>
-            </a:r>
-            <a:r>
-              <a:rPr lang="da-DK" sz="1300" dirty="0">
-                <a:latin typeface="Consolas" pitchFamily="49" charset="0"/>
-                <a:cs typeface="Consolas" pitchFamily="49" charset="0"/>
-              </a:rPr>
-              <a:t>::</a:t>
-            </a:r>
-            <a:r>
-              <a:rPr lang="da-DK" sz="1300" dirty="0" err="1">
-                <a:latin typeface="Consolas" pitchFamily="49" charset="0"/>
-                <a:cs typeface="Consolas" pitchFamily="49" charset="0"/>
-              </a:rPr>
-              <a:t>printText</a:t>
-            </a:r>
-            <a:r>
-              <a:rPr lang="da-DK" sz="1300" dirty="0">
-                <a:latin typeface="Consolas" pitchFamily="49" charset="0"/>
-                <a:cs typeface="Consolas" pitchFamily="49" charset="0"/>
-              </a:rPr>
-              <a:t>(</a:t>
-            </a:r>
-            <a:r>
-              <a:rPr lang="da-DK" sz="1300" dirty="0" err="1">
-                <a:latin typeface="Consolas" pitchFamily="49" charset="0"/>
-                <a:cs typeface="Consolas" pitchFamily="49" charset="0"/>
-              </a:rPr>
-              <a:t>text</a:t>
-            </a:r>
-            <a:r>
-              <a:rPr lang="da-DK" sz="1300" dirty="0">
-                <a:latin typeface="Consolas" pitchFamily="49" charset="0"/>
-                <a:cs typeface="Consolas" pitchFamily="49" charset="0"/>
-              </a:rPr>
-              <a:t> t)</a:t>
-            </a:r>
-          </a:p>
-          <a:p>
-            <a:r>
-              <a:rPr lang="da-DK" sz="1300" dirty="0">
-                <a:latin typeface="Consolas" pitchFamily="49" charset="0"/>
-                <a:cs typeface="Consolas" pitchFamily="49" charset="0"/>
-              </a:rPr>
-              <a:t>{</a:t>
-            </a:r>
-          </a:p>
-          <a:p>
-            <a:r>
-              <a:rPr lang="da-DK" sz="1300" dirty="0">
-                <a:latin typeface="Consolas" pitchFamily="49" charset="0"/>
-                <a:cs typeface="Consolas" pitchFamily="49" charset="0"/>
-              </a:rPr>
-              <a:t>  for </a:t>
-            </a:r>
-            <a:r>
-              <a:rPr lang="da-DK" sz="1300" dirty="0" err="1">
-                <a:latin typeface="Consolas" pitchFamily="49" charset="0"/>
-                <a:cs typeface="Consolas" pitchFamily="49" charset="0"/>
-              </a:rPr>
-              <a:t>each</a:t>
-            </a:r>
-            <a:r>
-              <a:rPr lang="da-DK" sz="1300" dirty="0">
-                <a:latin typeface="Consolas" pitchFamily="49" charset="0"/>
-                <a:cs typeface="Consolas" pitchFamily="49" charset="0"/>
-              </a:rPr>
-              <a:t> </a:t>
-            </a:r>
-            <a:r>
-              <a:rPr lang="da-DK" sz="1300" dirty="0" err="1">
-                <a:latin typeface="Consolas" pitchFamily="49" charset="0"/>
-                <a:cs typeface="Consolas" pitchFamily="49" charset="0"/>
-              </a:rPr>
-              <a:t>char</a:t>
-            </a:r>
-            <a:r>
-              <a:rPr lang="da-DK" sz="1300" dirty="0">
-                <a:latin typeface="Consolas" pitchFamily="49" charset="0"/>
-                <a:cs typeface="Consolas" pitchFamily="49" charset="0"/>
-              </a:rPr>
-              <a:t> c in t:</a:t>
-            </a:r>
-          </a:p>
-          <a:p>
-            <a:r>
-              <a:rPr lang="da-DK" sz="1300" dirty="0">
-                <a:latin typeface="Consolas" pitchFamily="49" charset="0"/>
-                <a:cs typeface="Consolas" pitchFamily="49" charset="0"/>
+              <a:rPr lang="en-US" sz="1400" dirty="0">
+                <a:latin typeface="Consolas" panose="020B0609020204030204" pitchFamily="49" charset="0"/>
+                <a:cs typeface="Consolas" panose="020B0609020204030204" pitchFamily="49" charset="0"/>
+              </a:rPr>
+              <a:t>public class </a:t>
+            </a:r>
+            <a:r>
+              <a:rPr lang="en-US" sz="1400" dirty="0" err="1">
+                <a:latin typeface="Consolas" panose="020B0609020204030204" pitchFamily="49" charset="0"/>
+                <a:cs typeface="Consolas" panose="020B0609020204030204" pitchFamily="49" charset="0"/>
+              </a:rPr>
+              <a:t>YeOldPrinter</a:t>
+            </a:r>
+            <a:r>
+              <a:rPr lang="en-US" sz="1400" dirty="0">
+                <a:latin typeface="Consolas" panose="020B0609020204030204" pitchFamily="49" charset="0"/>
+                <a:cs typeface="Consolas" panose="020B0609020204030204" pitchFamily="49" charset="0"/>
+              </a:rPr>
+              <a:t> : </a:t>
+            </a:r>
+            <a:r>
+              <a:rPr lang="en-US" sz="1400" dirty="0" err="1">
+                <a:latin typeface="Consolas" panose="020B0609020204030204" pitchFamily="49" charset="0"/>
+                <a:cs typeface="Consolas" panose="020B0609020204030204" pitchFamily="49" charset="0"/>
+              </a:rPr>
+              <a:t>Iprinter</a:t>
+            </a:r>
+            <a:r>
+              <a:rPr lang="en-US" sz="1400" dirty="0">
+                <a:latin typeface="Consolas" panose="020B0609020204030204" pitchFamily="49" charset="0"/>
+                <a:cs typeface="Consolas" panose="020B0609020204030204" pitchFamily="49" charset="0"/>
+              </a:rPr>
+              <a:t> {</a:t>
+            </a:r>
+            <a:br>
+              <a:rPr lang="en-US" sz="1400" dirty="0">
+                <a:latin typeface="Consolas" panose="020B0609020204030204" pitchFamily="49" charset="0"/>
+                <a:cs typeface="Consolas" panose="020B0609020204030204" pitchFamily="49" charset="0"/>
+              </a:rPr>
+            </a:br>
+            <a:r>
+              <a:rPr lang="en-US" sz="1400" dirty="0">
+                <a:latin typeface="Consolas" panose="020B0609020204030204" pitchFamily="49" charset="0"/>
+                <a:cs typeface="Consolas" panose="020B0609020204030204" pitchFamily="49" charset="0"/>
+              </a:rPr>
+              <a:t>    public void Print(string text) {</a:t>
+            </a:r>
+            <a:br>
+              <a:rPr lang="en-US" sz="1400" dirty="0">
+                <a:latin typeface="Consolas" panose="020B0609020204030204" pitchFamily="49" charset="0"/>
+                <a:cs typeface="Consolas" panose="020B0609020204030204" pitchFamily="49" charset="0"/>
+              </a:rPr>
+            </a:br>
+            <a:r>
+              <a:rPr lang="en-US" sz="1400" dirty="0">
+                <a:latin typeface="Consolas" panose="020B0609020204030204" pitchFamily="49" charset="0"/>
+                <a:cs typeface="Consolas" panose="020B0609020204030204" pitchFamily="49" charset="0"/>
+              </a:rPr>
+              <a:t>        foreach (char c in text) {</a:t>
+            </a:r>
+            <a:br>
+              <a:rPr lang="en-US" sz="1400" dirty="0">
+                <a:latin typeface="Consolas" panose="020B0609020204030204" pitchFamily="49" charset="0"/>
+                <a:cs typeface="Consolas" panose="020B0609020204030204" pitchFamily="49" charset="0"/>
+              </a:rPr>
+            </a:br>
+            <a:r>
+              <a:rPr lang="en-US" sz="1400" dirty="0">
+                <a:latin typeface="Consolas" panose="020B0609020204030204" pitchFamily="49" charset="0"/>
+                <a:cs typeface="Consolas" panose="020B0609020204030204" pitchFamily="49" charset="0"/>
+              </a:rPr>
+              <a:t>            </a:t>
+            </a:r>
+            <a:r>
+              <a:rPr lang="en-US" sz="1400" dirty="0" err="1">
+                <a:latin typeface="Consolas" panose="020B0609020204030204" pitchFamily="49" charset="0"/>
+                <a:cs typeface="Consolas" panose="020B0609020204030204" pitchFamily="49" charset="0"/>
+              </a:rPr>
+              <a:t>PrintChar</a:t>
+            </a:r>
+            <a:r>
+              <a:rPr lang="en-US" sz="1400" dirty="0">
+                <a:latin typeface="Consolas" panose="020B0609020204030204" pitchFamily="49" charset="0"/>
+                <a:cs typeface="Consolas" panose="020B0609020204030204" pitchFamily="49" charset="0"/>
+              </a:rPr>
+              <a:t>(c);</a:t>
+            </a:r>
+            <a:br>
+              <a:rPr lang="en-US" sz="1400" dirty="0">
+                <a:latin typeface="Consolas" panose="020B0609020204030204" pitchFamily="49" charset="0"/>
+                <a:cs typeface="Consolas" panose="020B0609020204030204" pitchFamily="49" charset="0"/>
+              </a:rPr>
+            </a:br>
+            <a:r>
+              <a:rPr lang="en-US" sz="1400" dirty="0">
+                <a:latin typeface="Consolas" panose="020B0609020204030204" pitchFamily="49" charset="0"/>
+                <a:cs typeface="Consolas" panose="020B0609020204030204" pitchFamily="49" charset="0"/>
+              </a:rPr>
+              <a:t>        }</a:t>
+            </a:r>
+            <a:br>
+              <a:rPr lang="en-US" sz="1400" dirty="0">
+                <a:latin typeface="Consolas" panose="020B0609020204030204" pitchFamily="49" charset="0"/>
+                <a:cs typeface="Consolas" panose="020B0609020204030204" pitchFamily="49" charset="0"/>
+              </a:rPr>
+            </a:br>
+            <a:r>
+              <a:rPr lang="en-US" sz="1400" dirty="0">
+                <a:latin typeface="Consolas" panose="020B0609020204030204" pitchFamily="49" charset="0"/>
+                <a:cs typeface="Consolas" panose="020B0609020204030204" pitchFamily="49" charset="0"/>
+              </a:rPr>
+              <a:t>    }</a:t>
+            </a:r>
+            <a:br>
+              <a:rPr lang="en-US" sz="1400" dirty="0">
+                <a:latin typeface="Consolas" panose="020B0609020204030204" pitchFamily="49" charset="0"/>
+                <a:cs typeface="Consolas" panose="020B0609020204030204" pitchFamily="49" charset="0"/>
+              </a:rPr>
+            </a:br>
+            <a:r>
+              <a:rPr lang="en-US" sz="1400" dirty="0">
+                <a:latin typeface="Consolas" panose="020B0609020204030204" pitchFamily="49" charset="0"/>
+                <a:cs typeface="Consolas" panose="020B0609020204030204" pitchFamily="49" charset="0"/>
+              </a:rPr>
+              <a:t>    private void </a:t>
+            </a:r>
+            <a:r>
+              <a:rPr lang="en-US" sz="1400" dirty="0" err="1">
+                <a:latin typeface="Consolas" panose="020B0609020204030204" pitchFamily="49" charset="0"/>
+                <a:cs typeface="Consolas" panose="020B0609020204030204" pitchFamily="49" charset="0"/>
+              </a:rPr>
+              <a:t>PrintChar</a:t>
+            </a:r>
+            <a:r>
+              <a:rPr lang="en-US" sz="1400" dirty="0">
+                <a:latin typeface="Consolas" panose="020B0609020204030204" pitchFamily="49" charset="0"/>
+                <a:cs typeface="Consolas" panose="020B0609020204030204" pitchFamily="49" charset="0"/>
+              </a:rPr>
+              <a:t>(char c) {</a:t>
+            </a:r>
+            <a:br>
+              <a:rPr lang="en-US" sz="1400" dirty="0">
+                <a:latin typeface="Consolas" panose="020B0609020204030204" pitchFamily="49" charset="0"/>
+                <a:cs typeface="Consolas" panose="020B0609020204030204" pitchFamily="49" charset="0"/>
+              </a:rPr>
+            </a:br>
+            <a:r>
+              <a:rPr lang="en-US" sz="1400" dirty="0">
+                <a:latin typeface="Consolas" panose="020B0609020204030204" pitchFamily="49" charset="0"/>
+                <a:cs typeface="Consolas" panose="020B0609020204030204" pitchFamily="49" charset="0"/>
+              </a:rPr>
+              <a:t>        </a:t>
+            </a:r>
+            <a:r>
+              <a:rPr lang="en-US" sz="1400" i="1" dirty="0">
+                <a:latin typeface="Consolas" panose="020B0609020204030204" pitchFamily="49" charset="0"/>
+                <a:cs typeface="Consolas" panose="020B0609020204030204" pitchFamily="49" charset="0"/>
+              </a:rPr>
+              <a:t>// .. print c on paper</a:t>
+            </a:r>
+            <a:br>
+              <a:rPr lang="en-US" sz="1400" i="1" dirty="0">
+                <a:latin typeface="Consolas" panose="020B0609020204030204" pitchFamily="49" charset="0"/>
+                <a:cs typeface="Consolas" panose="020B0609020204030204" pitchFamily="49" charset="0"/>
+              </a:rPr>
+            </a:br>
+            <a:r>
+              <a:rPr lang="en-US" sz="1400" i="1" dirty="0">
+                <a:latin typeface="Consolas" panose="020B0609020204030204" pitchFamily="49" charset="0"/>
+                <a:cs typeface="Consolas" panose="020B0609020204030204" pitchFamily="49" charset="0"/>
               </a:rPr>
               <a:t>    </a:t>
             </a:r>
             <a:r>
-              <a:rPr lang="da-DK" sz="1300" dirty="0" err="1">
-                <a:latin typeface="Consolas" pitchFamily="49" charset="0"/>
-                <a:cs typeface="Consolas" pitchFamily="49" charset="0"/>
-              </a:rPr>
-              <a:t>printChar</a:t>
-            </a:r>
-            <a:r>
-              <a:rPr lang="da-DK" sz="1300" dirty="0">
-                <a:latin typeface="Consolas" pitchFamily="49" charset="0"/>
-                <a:cs typeface="Consolas" pitchFamily="49" charset="0"/>
-              </a:rPr>
-              <a:t>(c);</a:t>
-            </a:r>
-          </a:p>
-          <a:p>
-            <a:r>
-              <a:rPr lang="da-DK" sz="1300" dirty="0">
-                <a:latin typeface="Consolas" pitchFamily="49" charset="0"/>
-                <a:cs typeface="Consolas" pitchFamily="49" charset="0"/>
+              <a:rPr lang="en-US" sz="1400" dirty="0">
+                <a:latin typeface="Consolas" panose="020B0609020204030204" pitchFamily="49" charset="0"/>
+                <a:cs typeface="Consolas" panose="020B0609020204030204" pitchFamily="49" charset="0"/>
               </a:rPr>
               <a:t>}</a:t>
             </a:r>
-          </a:p>
-          <a:p>
-            <a:endParaRPr lang="da-DK" sz="1300" dirty="0">
-              <a:latin typeface="Consolas" pitchFamily="49" charset="0"/>
-              <a:cs typeface="Consolas" pitchFamily="49" charset="0"/>
-            </a:endParaRPr>
-          </a:p>
-          <a:p>
-            <a:r>
-              <a:rPr lang="da-DK" sz="1300" dirty="0" err="1">
-                <a:latin typeface="Consolas" pitchFamily="49" charset="0"/>
-                <a:cs typeface="Consolas" pitchFamily="49" charset="0"/>
-              </a:rPr>
-              <a:t>void</a:t>
-            </a:r>
-            <a:r>
-              <a:rPr lang="da-DK" sz="1300" dirty="0">
-                <a:latin typeface="Consolas" pitchFamily="49" charset="0"/>
-                <a:cs typeface="Consolas" pitchFamily="49" charset="0"/>
-              </a:rPr>
-              <a:t> </a:t>
-            </a:r>
-            <a:r>
-              <a:rPr lang="da-DK" sz="1300" dirty="0" err="1">
-                <a:latin typeface="Consolas" pitchFamily="49" charset="0"/>
-                <a:cs typeface="Consolas" pitchFamily="49" charset="0"/>
-              </a:rPr>
-              <a:t>printChar</a:t>
-            </a:r>
-            <a:r>
-              <a:rPr lang="da-DK" sz="1300" dirty="0">
-                <a:latin typeface="Consolas" pitchFamily="49" charset="0"/>
-                <a:cs typeface="Consolas" pitchFamily="49" charset="0"/>
-              </a:rPr>
-              <a:t>(</a:t>
-            </a:r>
-            <a:r>
-              <a:rPr lang="da-DK" sz="1300" dirty="0" err="1">
-                <a:latin typeface="Consolas" pitchFamily="49" charset="0"/>
-                <a:cs typeface="Consolas" pitchFamily="49" charset="0"/>
-              </a:rPr>
-              <a:t>char</a:t>
-            </a:r>
-            <a:r>
-              <a:rPr lang="da-DK" sz="1300" dirty="0">
-                <a:latin typeface="Consolas" pitchFamily="49" charset="0"/>
-                <a:cs typeface="Consolas" pitchFamily="49" charset="0"/>
-              </a:rPr>
-              <a:t> c)</a:t>
-            </a:r>
-          </a:p>
-          <a:p>
-            <a:r>
-              <a:rPr lang="da-DK" sz="1300" dirty="0">
-                <a:latin typeface="Consolas" pitchFamily="49" charset="0"/>
-                <a:cs typeface="Consolas" pitchFamily="49" charset="0"/>
-              </a:rPr>
-              <a:t>{</a:t>
-            </a:r>
-          </a:p>
-          <a:p>
-            <a:r>
-              <a:rPr lang="da-DK" sz="1300" dirty="0">
-                <a:latin typeface="Consolas" pitchFamily="49" charset="0"/>
-                <a:cs typeface="Consolas" pitchFamily="49" charset="0"/>
-              </a:rPr>
-              <a:t>  // </a:t>
-            </a:r>
-            <a:r>
-              <a:rPr lang="da-DK" sz="1300" dirty="0" err="1">
-                <a:latin typeface="Consolas" pitchFamily="49" charset="0"/>
-                <a:cs typeface="Consolas" pitchFamily="49" charset="0"/>
-              </a:rPr>
-              <a:t>Whatever</a:t>
-            </a:r>
-            <a:r>
-              <a:rPr lang="da-DK" sz="1300" dirty="0">
-                <a:latin typeface="Consolas" pitchFamily="49" charset="0"/>
-                <a:cs typeface="Consolas" pitchFamily="49" charset="0"/>
-              </a:rPr>
-              <a:t> it </a:t>
-            </a:r>
-            <a:r>
-              <a:rPr lang="da-DK" sz="1300" dirty="0" err="1">
-                <a:latin typeface="Consolas" pitchFamily="49" charset="0"/>
-                <a:cs typeface="Consolas" pitchFamily="49" charset="0"/>
-              </a:rPr>
-              <a:t>takes</a:t>
-            </a:r>
-            <a:r>
-              <a:rPr lang="da-DK" sz="1300" dirty="0">
-                <a:latin typeface="Consolas" pitchFamily="49" charset="0"/>
-                <a:cs typeface="Consolas" pitchFamily="49" charset="0"/>
-              </a:rPr>
-              <a:t> to put ‘c’ on </a:t>
-            </a:r>
-            <a:r>
-              <a:rPr lang="da-DK" sz="1300" dirty="0" err="1">
-                <a:latin typeface="Consolas" pitchFamily="49" charset="0"/>
-                <a:cs typeface="Consolas" pitchFamily="49" charset="0"/>
-              </a:rPr>
-              <a:t>paper</a:t>
-            </a:r>
-            <a:endParaRPr lang="da-DK" sz="1300" dirty="0">
-              <a:latin typeface="Consolas" pitchFamily="49" charset="0"/>
-              <a:cs typeface="Consolas" pitchFamily="49" charset="0"/>
-            </a:endParaRPr>
-          </a:p>
-          <a:p>
-            <a:r>
-              <a:rPr lang="da-DK" sz="1300" dirty="0">
-                <a:latin typeface="Consolas" pitchFamily="49" charset="0"/>
-                <a:cs typeface="Consolas" pitchFamily="49" charset="0"/>
+            <a:br>
+              <a:rPr lang="en-US" sz="1400" dirty="0">
+                <a:latin typeface="Consolas" panose="020B0609020204030204" pitchFamily="49" charset="0"/>
+                <a:cs typeface="Consolas" panose="020B0609020204030204" pitchFamily="49" charset="0"/>
+              </a:rPr>
+            </a:br>
+            <a:r>
+              <a:rPr lang="en-US" sz="1400" dirty="0">
+                <a:latin typeface="Consolas" panose="020B0609020204030204" pitchFamily="49" charset="0"/>
+                <a:cs typeface="Consolas" panose="020B0609020204030204" pitchFamily="49" charset="0"/>
               </a:rPr>
               <a:t>}</a:t>
             </a:r>
@@ -3842,8 +3786,8 @@
         </p:nvSpPr>
         <p:spPr>
           <a:xfrm>
-            <a:off x="479778" y="4542855"/>
-            <a:ext cx="3732181" cy="1892826"/>
+            <a:off x="189704" y="4542855"/>
+            <a:ext cx="4310289" cy="1815882"/>
           </a:xfrm>
           <a:prstGeom prst="rect">
             <a:avLst/>
@@ -3871,183 +3815,184 @@
           <a:lstStyle/>
           <a:p>
             <a:r>
-              <a:rPr lang="da-DK" sz="1300" dirty="0" err="1">
-                <a:latin typeface="Consolas" pitchFamily="49" charset="0"/>
-                <a:cs typeface="Consolas" pitchFamily="49" charset="0"/>
+              <a:rPr lang="en-US" sz="1400" dirty="0">
+                <a:latin typeface="Consolas" panose="020B0609020204030204" pitchFamily="49" charset="0"/>
+                <a:cs typeface="Consolas" panose="020B0609020204030204" pitchFamily="49" charset="0"/>
+              </a:rPr>
+              <a:t>public class </a:t>
+            </a:r>
+            <a:r>
+              <a:rPr lang="en-US" sz="1400" dirty="0" err="1">
+                <a:latin typeface="Consolas" panose="020B0609020204030204" pitchFamily="49" charset="0"/>
+                <a:cs typeface="Consolas" panose="020B0609020204030204" pitchFamily="49" charset="0"/>
               </a:rPr>
               <a:t>TextEditor</a:t>
             </a:r>
             <a:r>
-              <a:rPr lang="da-DK" sz="1300" dirty="0">
-                <a:latin typeface="Consolas" pitchFamily="49" charset="0"/>
-                <a:cs typeface="Consolas" pitchFamily="49" charset="0"/>
-              </a:rPr>
-              <a:t>::</a:t>
-            </a:r>
-            <a:r>
-              <a:rPr lang="da-DK" sz="1300" dirty="0" err="1">
-                <a:latin typeface="Consolas" pitchFamily="49" charset="0"/>
-                <a:cs typeface="Consolas" pitchFamily="49" charset="0"/>
+              <a:rPr lang="en-US" sz="1400" dirty="0">
+                <a:latin typeface="Consolas" panose="020B0609020204030204" pitchFamily="49" charset="0"/>
+                <a:cs typeface="Consolas" panose="020B0609020204030204" pitchFamily="49" charset="0"/>
+              </a:rPr>
+              <a:t> {</a:t>
+            </a:r>
+            <a:br>
+              <a:rPr lang="en-US" sz="1400" dirty="0">
+                <a:latin typeface="Consolas" panose="020B0609020204030204" pitchFamily="49" charset="0"/>
+                <a:cs typeface="Consolas" panose="020B0609020204030204" pitchFamily="49" charset="0"/>
+              </a:rPr>
+            </a:br>
+            <a:r>
+              <a:rPr lang="en-US" sz="1400" dirty="0">
+                <a:latin typeface="Consolas" panose="020B0609020204030204" pitchFamily="49" charset="0"/>
+                <a:cs typeface="Consolas" panose="020B0609020204030204" pitchFamily="49" charset="0"/>
+              </a:rPr>
+              <a:t>    public </a:t>
+            </a:r>
+            <a:r>
+              <a:rPr lang="en-US" sz="1400" dirty="0" err="1">
+                <a:latin typeface="Consolas" panose="020B0609020204030204" pitchFamily="49" charset="0"/>
+                <a:cs typeface="Consolas" panose="020B0609020204030204" pitchFamily="49" charset="0"/>
               </a:rPr>
               <a:t>TextEditor</a:t>
             </a:r>
             <a:r>
-              <a:rPr lang="da-DK" sz="1300" dirty="0">
-                <a:latin typeface="Consolas" pitchFamily="49" charset="0"/>
-                <a:cs typeface="Consolas" pitchFamily="49" charset="0"/>
+              <a:rPr lang="en-US" sz="1400" dirty="0">
+                <a:latin typeface="Consolas" panose="020B0609020204030204" pitchFamily="49" charset="0"/>
+                <a:cs typeface="Consolas" panose="020B0609020204030204" pitchFamily="49" charset="0"/>
               </a:rPr>
               <a:t>(</a:t>
             </a:r>
             <a:r>
-              <a:rPr lang="da-DK" sz="1300" b="1" dirty="0" err="1">
-                <a:latin typeface="Consolas" pitchFamily="49" charset="0"/>
-                <a:cs typeface="Consolas" pitchFamily="49" charset="0"/>
+              <a:rPr lang="en-US" sz="1400" dirty="0" err="1">
+                <a:latin typeface="Consolas" panose="020B0609020204030204" pitchFamily="49" charset="0"/>
+                <a:cs typeface="Consolas" panose="020B0609020204030204" pitchFamily="49" charset="0"/>
               </a:rPr>
               <a:t>IPrinter</a:t>
             </a:r>
             <a:r>
-              <a:rPr lang="da-DK" sz="1300" b="1" dirty="0">
-                <a:latin typeface="Consolas" pitchFamily="49" charset="0"/>
-                <a:cs typeface="Consolas" pitchFamily="49" charset="0"/>
-              </a:rPr>
-              <a:t> p</a:t>
-            </a:r>
-            <a:r>
-              <a:rPr lang="da-DK" sz="1300" dirty="0">
-                <a:latin typeface="Consolas" pitchFamily="49" charset="0"/>
-                <a:cs typeface="Consolas" pitchFamily="49" charset="0"/>
-              </a:rPr>
-              <a:t>)</a:t>
-            </a:r>
-          </a:p>
-          <a:p>
-            <a:r>
-              <a:rPr lang="da-DK" sz="1300" dirty="0">
-                <a:latin typeface="Consolas" pitchFamily="49" charset="0"/>
-                <a:cs typeface="Consolas" pitchFamily="49" charset="0"/>
-              </a:rPr>
-              <a:t>{</a:t>
-            </a:r>
-          </a:p>
-          <a:p>
-            <a:r>
-              <a:rPr lang="da-DK" sz="1300" dirty="0">
-                <a:latin typeface="Consolas" pitchFamily="49" charset="0"/>
-                <a:cs typeface="Consolas" pitchFamily="49" charset="0"/>
-              </a:rPr>
-              <a:t>  printer = p</a:t>
-            </a:r>
-          </a:p>
-          <a:p>
-            <a:r>
-              <a:rPr lang="da-DK" sz="1300" dirty="0">
-                <a:latin typeface="Consolas" pitchFamily="49" charset="0"/>
-                <a:cs typeface="Consolas" pitchFamily="49" charset="0"/>
-              </a:rPr>
-              <a:t>}</a:t>
-            </a:r>
-          </a:p>
-          <a:p>
-            <a:endParaRPr lang="da-DK" sz="1300" dirty="0">
-              <a:latin typeface="Consolas" pitchFamily="49" charset="0"/>
-              <a:cs typeface="Consolas" pitchFamily="49" charset="0"/>
-            </a:endParaRPr>
-          </a:p>
-          <a:p>
-            <a:r>
-              <a:rPr lang="da-DK" sz="1300" dirty="0" err="1">
-                <a:latin typeface="Consolas" pitchFamily="49" charset="0"/>
-                <a:cs typeface="Consolas" pitchFamily="49" charset="0"/>
-              </a:rPr>
-              <a:t>void</a:t>
-            </a:r>
-            <a:r>
-              <a:rPr lang="da-DK" sz="1300" dirty="0">
-                <a:latin typeface="Consolas" pitchFamily="49" charset="0"/>
-                <a:cs typeface="Consolas" pitchFamily="49" charset="0"/>
-              </a:rPr>
-              <a:t> </a:t>
-            </a:r>
-            <a:r>
-              <a:rPr lang="da-DK" sz="1300" dirty="0" err="1">
-                <a:latin typeface="Consolas" pitchFamily="49" charset="0"/>
-                <a:cs typeface="Consolas" pitchFamily="49" charset="0"/>
-              </a:rPr>
-              <a:t>TextEditor</a:t>
-            </a:r>
-            <a:r>
-              <a:rPr lang="da-DK" sz="1300" dirty="0">
-                <a:latin typeface="Consolas" pitchFamily="49" charset="0"/>
-                <a:cs typeface="Consolas" pitchFamily="49" charset="0"/>
-              </a:rPr>
-              <a:t>::</a:t>
-            </a:r>
-            <a:r>
-              <a:rPr lang="da-DK" sz="1300" dirty="0" err="1">
-                <a:latin typeface="Consolas" pitchFamily="49" charset="0"/>
-                <a:cs typeface="Consolas" pitchFamily="49" charset="0"/>
-              </a:rPr>
-              <a:t>OnButtonPrint</a:t>
-            </a:r>
-            <a:r>
-              <a:rPr lang="da-DK" sz="1300" dirty="0">
-                <a:latin typeface="Consolas" pitchFamily="49" charset="0"/>
-                <a:cs typeface="Consolas" pitchFamily="49" charset="0"/>
-              </a:rPr>
-              <a:t>()</a:t>
-            </a:r>
-          </a:p>
-          <a:p>
-            <a:r>
-              <a:rPr lang="da-DK" sz="1300" dirty="0">
-                <a:latin typeface="Consolas" pitchFamily="49" charset="0"/>
-                <a:cs typeface="Consolas" pitchFamily="49" charset="0"/>
-              </a:rPr>
-              <a:t>{</a:t>
-            </a:r>
-          </a:p>
-          <a:p>
-            <a:r>
-              <a:rPr lang="da-DK" sz="1300" dirty="0">
-                <a:latin typeface="Consolas" pitchFamily="49" charset="0"/>
-                <a:cs typeface="Consolas" pitchFamily="49" charset="0"/>
-              </a:rPr>
-              <a:t>  </a:t>
-            </a:r>
-            <a:r>
-              <a:rPr lang="da-DK" sz="1300" dirty="0" err="1">
-                <a:latin typeface="Consolas" pitchFamily="49" charset="0"/>
-                <a:cs typeface="Consolas" pitchFamily="49" charset="0"/>
-              </a:rPr>
-              <a:t>printer.printText</a:t>
-            </a:r>
-            <a:r>
-              <a:rPr lang="da-DK" sz="1300" dirty="0">
-                <a:latin typeface="Consolas" pitchFamily="49" charset="0"/>
-                <a:cs typeface="Consolas" pitchFamily="49" charset="0"/>
-              </a:rPr>
-              <a:t>(</a:t>
-            </a:r>
-            <a:r>
-              <a:rPr lang="da-DK" sz="1300" dirty="0" err="1">
-                <a:latin typeface="Consolas" pitchFamily="49" charset="0"/>
-                <a:cs typeface="Consolas" pitchFamily="49" charset="0"/>
-              </a:rPr>
-              <a:t>currentText</a:t>
-            </a:r>
-            <a:r>
-              <a:rPr lang="da-DK" sz="1300" dirty="0">
-                <a:latin typeface="Consolas" pitchFamily="49" charset="0"/>
-                <a:cs typeface="Consolas" pitchFamily="49" charset="0"/>
-              </a:rPr>
-              <a:t>)</a:t>
-            </a:r>
-          </a:p>
-          <a:p>
-            <a:r>
-              <a:rPr lang="da-DK" sz="1300" dirty="0">
-                <a:latin typeface="Consolas" pitchFamily="49" charset="0"/>
-                <a:cs typeface="Consolas" pitchFamily="49" charset="0"/>
+              <a:rPr lang="en-US" sz="1400" dirty="0">
+                <a:latin typeface="Consolas" panose="020B0609020204030204" pitchFamily="49" charset="0"/>
+                <a:cs typeface="Consolas" panose="020B0609020204030204" pitchFamily="49" charset="0"/>
+              </a:rPr>
+              <a:t> printer) {</a:t>
+            </a:r>
+            <a:br>
+              <a:rPr lang="en-US" sz="1400" dirty="0">
+                <a:latin typeface="Consolas" panose="020B0609020204030204" pitchFamily="49" charset="0"/>
+                <a:cs typeface="Consolas" panose="020B0609020204030204" pitchFamily="49" charset="0"/>
+              </a:rPr>
+            </a:br>
+            <a:r>
+              <a:rPr lang="en-US" sz="1400" dirty="0">
+                <a:latin typeface="Consolas" panose="020B0609020204030204" pitchFamily="49" charset="0"/>
+                <a:cs typeface="Consolas" panose="020B0609020204030204" pitchFamily="49" charset="0"/>
+              </a:rPr>
+              <a:t>        _printer = </a:t>
+            </a:r>
+            <a:r>
+              <a:rPr lang="en-US" sz="1400" dirty="0" err="1">
+                <a:latin typeface="Consolas" panose="020B0609020204030204" pitchFamily="49" charset="0"/>
+                <a:cs typeface="Consolas" panose="020B0609020204030204" pitchFamily="49" charset="0"/>
+              </a:rPr>
+              <a:t>IPrinter</a:t>
+            </a:r>
+            <a:r>
+              <a:rPr lang="en-US" sz="1400" dirty="0">
+                <a:latin typeface="Consolas" panose="020B0609020204030204" pitchFamily="49" charset="0"/>
+                <a:cs typeface="Consolas" panose="020B0609020204030204" pitchFamily="49" charset="0"/>
+              </a:rPr>
+              <a:t>;</a:t>
+            </a:r>
+            <a:br>
+              <a:rPr lang="en-US" sz="1400" dirty="0">
+                <a:latin typeface="Consolas" panose="020B0609020204030204" pitchFamily="49" charset="0"/>
+                <a:cs typeface="Consolas" panose="020B0609020204030204" pitchFamily="49" charset="0"/>
+              </a:rPr>
+            </a:br>
+            <a:r>
+              <a:rPr lang="en-US" sz="1400" dirty="0">
+                <a:latin typeface="Consolas" panose="020B0609020204030204" pitchFamily="49" charset="0"/>
+                <a:cs typeface="Consolas" panose="020B0609020204030204" pitchFamily="49" charset="0"/>
+              </a:rPr>
+              <a:t>    }</a:t>
+            </a:r>
+            <a:br>
+              <a:rPr lang="en-US" sz="1400" dirty="0">
+                <a:latin typeface="Consolas" panose="020B0609020204030204" pitchFamily="49" charset="0"/>
+                <a:cs typeface="Consolas" panose="020B0609020204030204" pitchFamily="49" charset="0"/>
+              </a:rPr>
+            </a:br>
+            <a:r>
+              <a:rPr lang="en-US" sz="1400" dirty="0">
+                <a:latin typeface="Consolas" panose="020B0609020204030204" pitchFamily="49" charset="0"/>
+                <a:cs typeface="Consolas" panose="020B0609020204030204" pitchFamily="49" charset="0"/>
+              </a:rPr>
+              <a:t>    public void </a:t>
+            </a:r>
+            <a:r>
+              <a:rPr lang="en-US" sz="1400" dirty="0" err="1">
+                <a:latin typeface="Consolas" panose="020B0609020204030204" pitchFamily="49" charset="0"/>
+                <a:cs typeface="Consolas" panose="020B0609020204030204" pitchFamily="49" charset="0"/>
+              </a:rPr>
+              <a:t>OnPrintButton</a:t>
+            </a:r>
+            <a:r>
+              <a:rPr lang="en-US" sz="1400" dirty="0">
+                <a:latin typeface="Consolas" panose="020B0609020204030204" pitchFamily="49" charset="0"/>
+                <a:cs typeface="Consolas" panose="020B0609020204030204" pitchFamily="49" charset="0"/>
+              </a:rPr>
+              <a:t>() {</a:t>
+            </a:r>
+            <a:br>
+              <a:rPr lang="en-US" sz="1400" dirty="0">
+                <a:latin typeface="Consolas" panose="020B0609020204030204" pitchFamily="49" charset="0"/>
+                <a:cs typeface="Consolas" panose="020B0609020204030204" pitchFamily="49" charset="0"/>
+              </a:rPr>
+            </a:br>
+            <a:r>
+              <a:rPr lang="en-US" sz="1400" dirty="0">
+                <a:latin typeface="Consolas" panose="020B0609020204030204" pitchFamily="49" charset="0"/>
+                <a:cs typeface="Consolas" panose="020B0609020204030204" pitchFamily="49" charset="0"/>
+              </a:rPr>
+              <a:t>        _</a:t>
+            </a:r>
+            <a:r>
+              <a:rPr lang="en-US" sz="1400" dirty="0" err="1">
+                <a:latin typeface="Consolas" panose="020B0609020204030204" pitchFamily="49" charset="0"/>
+                <a:cs typeface="Consolas" panose="020B0609020204030204" pitchFamily="49" charset="0"/>
+              </a:rPr>
+              <a:t>printer.Print</a:t>
+            </a:r>
+            <a:r>
+              <a:rPr lang="en-US" sz="1400" dirty="0">
+                <a:latin typeface="Consolas" panose="020B0609020204030204" pitchFamily="49" charset="0"/>
+                <a:cs typeface="Consolas" panose="020B0609020204030204" pitchFamily="49" charset="0"/>
+              </a:rPr>
+              <a:t>(text);</a:t>
+            </a:r>
+            <a:br>
+              <a:rPr lang="en-US" sz="1400" dirty="0">
+                <a:latin typeface="Consolas" panose="020B0609020204030204" pitchFamily="49" charset="0"/>
+                <a:cs typeface="Consolas" panose="020B0609020204030204" pitchFamily="49" charset="0"/>
+              </a:rPr>
+            </a:br>
+            <a:r>
+              <a:rPr lang="en-US" sz="1400" dirty="0">
+                <a:latin typeface="Consolas" panose="020B0609020204030204" pitchFamily="49" charset="0"/>
+                <a:cs typeface="Consolas" panose="020B0609020204030204" pitchFamily="49" charset="0"/>
+              </a:rPr>
+              <a:t>    }</a:t>
+            </a:r>
+            <a:br>
+              <a:rPr lang="en-US" sz="1400" dirty="0">
+                <a:latin typeface="Consolas" panose="020B0609020204030204" pitchFamily="49" charset="0"/>
+                <a:cs typeface="Consolas" panose="020B0609020204030204" pitchFamily="49" charset="0"/>
+              </a:rPr>
+            </a:br>
+            <a:r>
+              <a:rPr lang="en-US" sz="1400" dirty="0">
+                <a:latin typeface="Consolas" panose="020B0609020204030204" pitchFamily="49" charset="0"/>
+                <a:cs typeface="Consolas" panose="020B0609020204030204" pitchFamily="49" charset="0"/>
               </a:rPr>
               <a:t>}</a:t>
             </a:r>
@@ -4740,7 +4685,7 @@
               <a:rPr lang="da-DK" sz="1300" dirty="0">
                 <a:cs typeface="Consolas" pitchFamily="49" charset="0"/>
               </a:rPr>
-              <a:t>REQ 27: The </a:t>
+              <a:t>REQ 28: The </a:t>
             </a:r>
             <a:r>
               <a:rPr lang="da-DK" sz="1300" dirty="0" err="1">
@@ -4910,8 +4855,8 @@
         </p:nvSpPr>
         <p:spPr>
           <a:xfrm>
-            <a:off x="479778" y="4542855"/>
-            <a:ext cx="3732181" cy="1892826"/>
+            <a:off x="107504" y="4542855"/>
+            <a:ext cx="4320480" cy="1815882"/>
           </a:xfrm>
           <a:prstGeom prst="rect">
             <a:avLst/>
@@ -4939,183 +4884,184 @@
           <a:lstStyle/>
           <a:p>
             <a:r>
-              <a:rPr lang="da-DK" sz="1300" dirty="0" err="1">
-                <a:latin typeface="Consolas" pitchFamily="49" charset="0"/>
-                <a:cs typeface="Consolas" pitchFamily="49" charset="0"/>
+              <a:rPr lang="en-US" sz="1400" dirty="0">
+                <a:latin typeface="Consolas" panose="020B0609020204030204" pitchFamily="49" charset="0"/>
+                <a:cs typeface="Consolas" panose="020B0609020204030204" pitchFamily="49" charset="0"/>
+              </a:rPr>
+              <a:t>public class </a:t>
+            </a:r>
+            <a:r>
+              <a:rPr lang="en-US" sz="1400" dirty="0" err="1">
+                <a:latin typeface="Consolas" panose="020B0609020204030204" pitchFamily="49" charset="0"/>
+                <a:cs typeface="Consolas" panose="020B0609020204030204" pitchFamily="49" charset="0"/>
               </a:rPr>
               <a:t>TextEditor</a:t>
             </a:r>
             <a:r>
-              <a:rPr lang="da-DK" sz="1300" dirty="0">
-                <a:latin typeface="Consolas" pitchFamily="49" charset="0"/>
-                <a:cs typeface="Consolas" pitchFamily="49" charset="0"/>
-              </a:rPr>
-              <a:t>::</a:t>
-            </a:r>
-            <a:r>
-              <a:rPr lang="da-DK" sz="1300" dirty="0" err="1">
-                <a:latin typeface="Consolas" pitchFamily="49" charset="0"/>
-                <a:cs typeface="Consolas" pitchFamily="49" charset="0"/>
+              <a:rPr lang="en-US" sz="1400" dirty="0">
+                <a:latin typeface="Consolas" panose="020B0609020204030204" pitchFamily="49" charset="0"/>
+                <a:cs typeface="Consolas" panose="020B0609020204030204" pitchFamily="49" charset="0"/>
+              </a:rPr>
+              <a:t> {</a:t>
+            </a:r>
+            <a:br>
+              <a:rPr lang="en-US" sz="1400" dirty="0">
+                <a:latin typeface="Consolas" panose="020B0609020204030204" pitchFamily="49" charset="0"/>
+                <a:cs typeface="Consolas" panose="020B0609020204030204" pitchFamily="49" charset="0"/>
+              </a:rPr>
+            </a:br>
+            <a:r>
+              <a:rPr lang="en-US" sz="1400" dirty="0">
+                <a:latin typeface="Consolas" panose="020B0609020204030204" pitchFamily="49" charset="0"/>
+                <a:cs typeface="Consolas" panose="020B0609020204030204" pitchFamily="49" charset="0"/>
+              </a:rPr>
+              <a:t>    public </a:t>
+            </a:r>
+            <a:r>
+              <a:rPr lang="en-US" sz="1400" dirty="0" err="1">
+                <a:latin typeface="Consolas" panose="020B0609020204030204" pitchFamily="49" charset="0"/>
+                <a:cs typeface="Consolas" panose="020B0609020204030204" pitchFamily="49" charset="0"/>
               </a:rPr>
               <a:t>TextEditor</a:t>
             </a:r>
             <a:r>
-              <a:rPr lang="da-DK" sz="1300" dirty="0">
-                <a:latin typeface="Consolas" pitchFamily="49" charset="0"/>
-                <a:cs typeface="Consolas" pitchFamily="49" charset="0"/>
+              <a:rPr lang="en-US" sz="1400" dirty="0">
+                <a:latin typeface="Consolas" panose="020B0609020204030204" pitchFamily="49" charset="0"/>
+                <a:cs typeface="Consolas" panose="020B0609020204030204" pitchFamily="49" charset="0"/>
               </a:rPr>
               <a:t>(</a:t>
             </a:r>
             <a:r>
-              <a:rPr lang="da-DK" sz="1300" b="1" dirty="0" err="1">
-                <a:latin typeface="Consolas" pitchFamily="49" charset="0"/>
-                <a:cs typeface="Consolas" pitchFamily="49" charset="0"/>
+              <a:rPr lang="en-US" sz="1400" dirty="0" err="1">
+                <a:latin typeface="Consolas" panose="020B0609020204030204" pitchFamily="49" charset="0"/>
+                <a:cs typeface="Consolas" panose="020B0609020204030204" pitchFamily="49" charset="0"/>
               </a:rPr>
               <a:t>IPrinter</a:t>
             </a:r>
             <a:r>
-              <a:rPr lang="da-DK" sz="1300" b="1" dirty="0">
-                <a:latin typeface="Consolas" pitchFamily="49" charset="0"/>
-                <a:cs typeface="Consolas" pitchFamily="49" charset="0"/>
-              </a:rPr>
-              <a:t> p</a:t>
-            </a:r>
-            <a:r>
-              <a:rPr lang="da-DK" sz="1300" dirty="0">
-                <a:latin typeface="Consolas" pitchFamily="49" charset="0"/>
-                <a:cs typeface="Consolas" pitchFamily="49" charset="0"/>
-              </a:rPr>
-              <a:t>)</a:t>
-            </a:r>
-          </a:p>
-          <a:p>
-            <a:r>
-              <a:rPr lang="da-DK" sz="1300" dirty="0">
-                <a:latin typeface="Consolas" pitchFamily="49" charset="0"/>
-                <a:cs typeface="Consolas" pitchFamily="49" charset="0"/>
-              </a:rPr>
-              <a:t>{</a:t>
-            </a:r>
-          </a:p>
-          <a:p>
-            <a:r>
-              <a:rPr lang="da-DK" sz="1300" dirty="0">
-                <a:latin typeface="Consolas" pitchFamily="49" charset="0"/>
-                <a:cs typeface="Consolas" pitchFamily="49" charset="0"/>
-              </a:rPr>
-              <a:t>  printer = p</a:t>
-            </a:r>
-          </a:p>
-          <a:p>
-            <a:r>
-              <a:rPr lang="da-DK" sz="1300" dirty="0">
-                <a:latin typeface="Consolas" pitchFamily="49" charset="0"/>
-                <a:cs typeface="Consolas" pitchFamily="49" charset="0"/>
-              </a:rPr>
-              <a:t>}</a:t>
-            </a:r>
-          </a:p>
-          <a:p>
-            <a:endParaRPr lang="da-DK" sz="1300" dirty="0">
-              <a:latin typeface="Consolas" pitchFamily="49" charset="0"/>
-              <a:cs typeface="Consolas" pitchFamily="49" charset="0"/>
-            </a:endParaRPr>
-          </a:p>
-          <a:p>
-            <a:r>
-              <a:rPr lang="da-DK" sz="1300" dirty="0" err="1">
-                <a:latin typeface="Consolas" pitchFamily="49" charset="0"/>
-                <a:cs typeface="Consolas" pitchFamily="49" charset="0"/>
-              </a:rPr>
-              <a:t>void</a:t>
-            </a:r>
-            <a:r>
-              <a:rPr lang="da-DK" sz="1300" dirty="0">
-                <a:latin typeface="Consolas" pitchFamily="49" charset="0"/>
-                <a:cs typeface="Consolas" pitchFamily="49" charset="0"/>
-              </a:rPr>
-              <a:t> </a:t>
-            </a:r>
-            <a:r>
-              <a:rPr lang="da-DK" sz="1300" dirty="0" err="1">
-                <a:latin typeface="Consolas" pitchFamily="49" charset="0"/>
-                <a:cs typeface="Consolas" pitchFamily="49" charset="0"/>
-              </a:rPr>
-              <a:t>TextEditor</a:t>
-            </a:r>
-            <a:r>
-              <a:rPr lang="da-DK" sz="1300" dirty="0">
-                <a:latin typeface="Consolas" pitchFamily="49" charset="0"/>
-                <a:cs typeface="Consolas" pitchFamily="49" charset="0"/>
-              </a:rPr>
-              <a:t>::</a:t>
-            </a:r>
-            <a:r>
-              <a:rPr lang="da-DK" sz="1300" dirty="0" err="1">
-                <a:latin typeface="Consolas" pitchFamily="49" charset="0"/>
-                <a:cs typeface="Consolas" pitchFamily="49" charset="0"/>
-              </a:rPr>
-              <a:t>OnButtonPrint</a:t>
-            </a:r>
-            <a:r>
-              <a:rPr lang="da-DK" sz="1300" dirty="0">
-                <a:latin typeface="Consolas" pitchFamily="49" charset="0"/>
-                <a:cs typeface="Consolas" pitchFamily="49" charset="0"/>
-              </a:rPr>
-              <a:t>()</a:t>
-            </a:r>
-          </a:p>
-          <a:p>
-            <a:r>
-              <a:rPr lang="da-DK" sz="1300" dirty="0">
-                <a:latin typeface="Consolas" pitchFamily="49" charset="0"/>
-                <a:cs typeface="Consolas" pitchFamily="49" charset="0"/>
-              </a:rPr>
-              <a:t>{</a:t>
-            </a:r>
-          </a:p>
-          <a:p>
-            <a:r>
-              <a:rPr lang="da-DK" sz="1300" dirty="0">
-                <a:latin typeface="Consolas" pitchFamily="49" charset="0"/>
-                <a:cs typeface="Consolas" pitchFamily="49" charset="0"/>
-              </a:rPr>
-              <a:t>  </a:t>
-            </a:r>
-            <a:r>
-              <a:rPr lang="da-DK" sz="1300" dirty="0" err="1">
-                <a:latin typeface="Consolas" pitchFamily="49" charset="0"/>
-                <a:cs typeface="Consolas" pitchFamily="49" charset="0"/>
-              </a:rPr>
-              <a:t>printer.printText</a:t>
-            </a:r>
-            <a:r>
-              <a:rPr lang="da-DK" sz="1300" dirty="0">
-                <a:latin typeface="Consolas" pitchFamily="49" charset="0"/>
-                <a:cs typeface="Consolas" pitchFamily="49" charset="0"/>
-              </a:rPr>
-              <a:t>(</a:t>
-            </a:r>
-            <a:r>
-              <a:rPr lang="da-DK" sz="1300" dirty="0" err="1">
-                <a:latin typeface="Consolas" pitchFamily="49" charset="0"/>
-                <a:cs typeface="Consolas" pitchFamily="49" charset="0"/>
-              </a:rPr>
-              <a:t>currentText</a:t>
-            </a:r>
-            <a:r>
-              <a:rPr lang="da-DK" sz="1300" dirty="0">
-                <a:latin typeface="Consolas" pitchFamily="49" charset="0"/>
-                <a:cs typeface="Consolas" pitchFamily="49" charset="0"/>
-              </a:rPr>
-              <a:t>)</a:t>
-            </a:r>
-          </a:p>
-          <a:p>
-            <a:r>
-              <a:rPr lang="da-DK" sz="1300" dirty="0">
-                <a:latin typeface="Consolas" pitchFamily="49" charset="0"/>
-                <a:cs typeface="Consolas" pitchFamily="49" charset="0"/>
+              <a:rPr lang="en-US" sz="1400" dirty="0">
+                <a:latin typeface="Consolas" panose="020B0609020204030204" pitchFamily="49" charset="0"/>
+                <a:cs typeface="Consolas" panose="020B0609020204030204" pitchFamily="49" charset="0"/>
+              </a:rPr>
+              <a:t> printer) {</a:t>
+            </a:r>
+            <a:br>
+              <a:rPr lang="en-US" sz="1400" dirty="0">
+                <a:latin typeface="Consolas" panose="020B0609020204030204" pitchFamily="49" charset="0"/>
+                <a:cs typeface="Consolas" panose="020B0609020204030204" pitchFamily="49" charset="0"/>
+              </a:rPr>
+            </a:br>
+            <a:r>
+              <a:rPr lang="en-US" sz="1400" dirty="0">
+                <a:latin typeface="Consolas" panose="020B0609020204030204" pitchFamily="49" charset="0"/>
+                <a:cs typeface="Consolas" panose="020B0609020204030204" pitchFamily="49" charset="0"/>
+              </a:rPr>
+              <a:t>        _printer = </a:t>
+            </a:r>
+            <a:r>
+              <a:rPr lang="en-US" sz="1400" dirty="0" err="1">
+                <a:latin typeface="Consolas" panose="020B0609020204030204" pitchFamily="49" charset="0"/>
+                <a:cs typeface="Consolas" panose="020B0609020204030204" pitchFamily="49" charset="0"/>
+              </a:rPr>
+              <a:t>IPrinter</a:t>
+            </a:r>
+            <a:r>
+              <a:rPr lang="en-US" sz="1400" dirty="0">
+                <a:latin typeface="Consolas" panose="020B0609020204030204" pitchFamily="49" charset="0"/>
+                <a:cs typeface="Consolas" panose="020B0609020204030204" pitchFamily="49" charset="0"/>
+              </a:rPr>
+              <a:t>;</a:t>
+            </a:r>
+            <a:br>
+              <a:rPr lang="en-US" sz="1400" dirty="0">
+                <a:latin typeface="Consolas" panose="020B0609020204030204" pitchFamily="49" charset="0"/>
+                <a:cs typeface="Consolas" panose="020B0609020204030204" pitchFamily="49" charset="0"/>
+              </a:rPr>
+            </a:br>
+            <a:r>
+              <a:rPr lang="en-US" sz="1400" dirty="0">
+                <a:latin typeface="Consolas" panose="020B0609020204030204" pitchFamily="49" charset="0"/>
+                <a:cs typeface="Consolas" panose="020B0609020204030204" pitchFamily="49" charset="0"/>
+              </a:rPr>
+              <a:t>    }</a:t>
+            </a:r>
+            <a:br>
+              <a:rPr lang="en-US" sz="1400" dirty="0">
+                <a:latin typeface="Consolas" panose="020B0609020204030204" pitchFamily="49" charset="0"/>
+                <a:cs typeface="Consolas" panose="020B0609020204030204" pitchFamily="49" charset="0"/>
+              </a:rPr>
+            </a:br>
+            <a:r>
+              <a:rPr lang="en-US" sz="1400" dirty="0">
+                <a:latin typeface="Consolas" panose="020B0609020204030204" pitchFamily="49" charset="0"/>
+                <a:cs typeface="Consolas" panose="020B0609020204030204" pitchFamily="49" charset="0"/>
+              </a:rPr>
+              <a:t>    public void </a:t>
+            </a:r>
+            <a:r>
+              <a:rPr lang="en-US" sz="1400" dirty="0" err="1">
+                <a:latin typeface="Consolas" panose="020B0609020204030204" pitchFamily="49" charset="0"/>
+                <a:cs typeface="Consolas" panose="020B0609020204030204" pitchFamily="49" charset="0"/>
+              </a:rPr>
+              <a:t>OnPrintButton</a:t>
+            </a:r>
+            <a:r>
+              <a:rPr lang="en-US" sz="1400" dirty="0">
+                <a:latin typeface="Consolas" panose="020B0609020204030204" pitchFamily="49" charset="0"/>
+                <a:cs typeface="Consolas" panose="020B0609020204030204" pitchFamily="49" charset="0"/>
+              </a:rPr>
+              <a:t>() {</a:t>
+            </a:r>
+            <a:br>
+              <a:rPr lang="en-US" sz="1400" dirty="0">
+                <a:latin typeface="Consolas" panose="020B0609020204030204" pitchFamily="49" charset="0"/>
+                <a:cs typeface="Consolas" panose="020B0609020204030204" pitchFamily="49" charset="0"/>
+              </a:rPr>
+            </a:br>
+            <a:r>
+              <a:rPr lang="en-US" sz="1400" dirty="0">
+                <a:latin typeface="Consolas" panose="020B0609020204030204" pitchFamily="49" charset="0"/>
+                <a:cs typeface="Consolas" panose="020B0609020204030204" pitchFamily="49" charset="0"/>
+              </a:rPr>
+              <a:t>        _</a:t>
+            </a:r>
+            <a:r>
+              <a:rPr lang="en-US" sz="1400" dirty="0" err="1">
+                <a:latin typeface="Consolas" panose="020B0609020204030204" pitchFamily="49" charset="0"/>
+                <a:cs typeface="Consolas" panose="020B0609020204030204" pitchFamily="49" charset="0"/>
+              </a:rPr>
+              <a:t>printer.Print</a:t>
+            </a:r>
+            <a:r>
+              <a:rPr lang="en-US" sz="1400" dirty="0">
+                <a:latin typeface="Consolas" panose="020B0609020204030204" pitchFamily="49" charset="0"/>
+                <a:cs typeface="Consolas" panose="020B0609020204030204" pitchFamily="49" charset="0"/>
+              </a:rPr>
+              <a:t>(text);</a:t>
+            </a:r>
+            <a:br>
+              <a:rPr lang="en-US" sz="1400" dirty="0">
+                <a:latin typeface="Consolas" panose="020B0609020204030204" pitchFamily="49" charset="0"/>
+                <a:cs typeface="Consolas" panose="020B0609020204030204" pitchFamily="49" charset="0"/>
+              </a:rPr>
+            </a:br>
+            <a:r>
+              <a:rPr lang="en-US" sz="1400" dirty="0">
+                <a:latin typeface="Consolas" panose="020B0609020204030204" pitchFamily="49" charset="0"/>
+                <a:cs typeface="Consolas" panose="020B0609020204030204" pitchFamily="49" charset="0"/>
+              </a:rPr>
+              <a:t>    }</a:t>
+            </a:r>
+            <a:br>
+              <a:rPr lang="en-US" sz="1400" dirty="0">
+                <a:latin typeface="Consolas" panose="020B0609020204030204" pitchFamily="49" charset="0"/>
+                <a:cs typeface="Consolas" panose="020B0609020204030204" pitchFamily="49" charset="0"/>
+              </a:rPr>
+            </a:br>
+            <a:r>
+              <a:rPr lang="en-US" sz="1400" dirty="0">
+                <a:latin typeface="Consolas" panose="020B0609020204030204" pitchFamily="49" charset="0"/>
+                <a:cs typeface="Consolas" panose="020B0609020204030204" pitchFamily="49" charset="0"/>
               </a:rPr>
               <a:t>}</a:t>
             </a:r>
@@ -5131,7 +5077,7 @@
         <p:spPr>
           <a:xfrm>
             <a:off x="4644008" y="4576479"/>
-            <a:ext cx="4204997" cy="2092881"/>
+            <a:ext cx="4499992" cy="1815882"/>
           </a:xfrm>
           <a:prstGeom prst="rect">
             <a:avLst/>
@@ -5153,244 +5099,165 @@
           </a:effectLst>
         </p:spPr>
         <p:txBody>
-          <a:bodyPr wrap="none" rtlCol="0">
+          <a:bodyPr wrap="square" rtlCol="0">
             <a:spAutoFit/>
           </a:bodyPr>
           <a:lstStyle/>
           <a:p>
             <a:r>
-              <a:rPr lang="da-DK" sz="1300" dirty="0" err="1">
-                <a:latin typeface="Consolas" pitchFamily="49" charset="0"/>
-                <a:cs typeface="Consolas" pitchFamily="49" charset="0"/>
-              </a:rPr>
-              <a:t>void</a:t>
-            </a:r>
-            <a:r>
-              <a:rPr lang="da-DK" sz="1300" dirty="0">
-                <a:latin typeface="Consolas" pitchFamily="49" charset="0"/>
-                <a:cs typeface="Consolas" pitchFamily="49" charset="0"/>
-              </a:rPr>
-              <a:t> </a:t>
-            </a:r>
-            <a:r>
-              <a:rPr lang="da-DK" sz="1300" dirty="0" err="1">
-                <a:latin typeface="Consolas" pitchFamily="49" charset="0"/>
-                <a:cs typeface="Consolas" pitchFamily="49" charset="0"/>
-              </a:rPr>
-              <a:t>TheNewPrinterDriver</a:t>
-            </a:r>
-            <a:r>
-              <a:rPr lang="da-DK" sz="1300" dirty="0">
-                <a:latin typeface="Consolas" pitchFamily="49" charset="0"/>
-                <a:cs typeface="Consolas" pitchFamily="49" charset="0"/>
-              </a:rPr>
-              <a:t>::</a:t>
-            </a:r>
-            <a:r>
-              <a:rPr lang="da-DK" sz="1300" dirty="0" err="1">
-                <a:latin typeface="Consolas" pitchFamily="49" charset="0"/>
-                <a:cs typeface="Consolas" pitchFamily="49" charset="0"/>
-              </a:rPr>
-              <a:t>printText</a:t>
-            </a:r>
-            <a:r>
-              <a:rPr lang="da-DK" sz="1300" dirty="0">
-                <a:latin typeface="Consolas" pitchFamily="49" charset="0"/>
-                <a:cs typeface="Consolas" pitchFamily="49" charset="0"/>
-              </a:rPr>
-              <a:t>(</a:t>
-            </a:r>
-            <a:r>
-              <a:rPr lang="da-DK" sz="1300" dirty="0" err="1">
-                <a:latin typeface="Consolas" pitchFamily="49" charset="0"/>
-                <a:cs typeface="Consolas" pitchFamily="49" charset="0"/>
-              </a:rPr>
-              <a:t>text</a:t>
-            </a:r>
-            <a:r>
-              <a:rPr lang="da-DK" sz="1300" dirty="0">
-                <a:latin typeface="Consolas" pitchFamily="49" charset="0"/>
-                <a:cs typeface="Consolas" pitchFamily="49" charset="0"/>
-              </a:rPr>
-              <a:t> t)</a:t>
-            </a:r>
-          </a:p>
-          <a:p>
-            <a:r>
-              <a:rPr lang="da-DK" sz="1300" dirty="0">
-                <a:latin typeface="Consolas" pitchFamily="49" charset="0"/>
-                <a:cs typeface="Consolas" pitchFamily="49" charset="0"/>
-              </a:rPr>
-              <a:t>{</a:t>
-            </a:r>
-          </a:p>
-          <a:p>
-            <a:r>
-              <a:rPr lang="da-DK" sz="1300" dirty="0">
-                <a:latin typeface="Consolas" pitchFamily="49" charset="0"/>
-                <a:cs typeface="Consolas" pitchFamily="49" charset="0"/>
-              </a:rPr>
-              <a:t>  for </a:t>
-            </a:r>
-            <a:r>
-              <a:rPr lang="da-DK" sz="1300" dirty="0" err="1">
-                <a:latin typeface="Consolas" pitchFamily="49" charset="0"/>
-                <a:cs typeface="Consolas" pitchFamily="49" charset="0"/>
-              </a:rPr>
-              <a:t>each</a:t>
-            </a:r>
-            <a:r>
-              <a:rPr lang="da-DK" sz="1300" dirty="0">
-                <a:latin typeface="Consolas" pitchFamily="49" charset="0"/>
-                <a:cs typeface="Consolas" pitchFamily="49" charset="0"/>
-              </a:rPr>
-              <a:t> line l in t:</a:t>
-            </a:r>
-          </a:p>
-          <a:p>
-            <a:r>
-              <a:rPr lang="da-DK" sz="1300" dirty="0">
-                <a:latin typeface="Consolas" pitchFamily="49" charset="0"/>
-                <a:cs typeface="Consolas" pitchFamily="49" charset="0"/>
-              </a:rPr>
-              <a:t>    </a:t>
-            </a:r>
-            <a:r>
-              <a:rPr lang="da-DK" sz="1300" dirty="0" err="1">
-                <a:latin typeface="Consolas" pitchFamily="49" charset="0"/>
-                <a:cs typeface="Consolas" pitchFamily="49" charset="0"/>
+              <a:rPr lang="en-US" sz="1400" dirty="0">
+                <a:latin typeface="Consolas" panose="020B0609020204030204" pitchFamily="49" charset="0"/>
+                <a:cs typeface="Consolas" panose="020B0609020204030204" pitchFamily="49" charset="0"/>
+              </a:rPr>
+              <a:t>public class </a:t>
+            </a:r>
+            <a:r>
+              <a:rPr lang="en-US" sz="1400" dirty="0" err="1">
+                <a:latin typeface="Consolas" panose="020B0609020204030204" pitchFamily="49" charset="0"/>
+                <a:cs typeface="Consolas" panose="020B0609020204030204" pitchFamily="49" charset="0"/>
+              </a:rPr>
+              <a:t>TheNewPrinter</a:t>
+            </a:r>
+            <a:r>
+              <a:rPr lang="en-US" sz="1400" dirty="0">
+                <a:latin typeface="Consolas" panose="020B0609020204030204" pitchFamily="49" charset="0"/>
+                <a:cs typeface="Consolas" panose="020B0609020204030204" pitchFamily="49" charset="0"/>
+              </a:rPr>
+              <a:t> : </a:t>
+            </a:r>
+            <a:r>
+              <a:rPr lang="en-US" sz="1400" dirty="0" err="1">
+                <a:latin typeface="Consolas" panose="020B0609020204030204" pitchFamily="49" charset="0"/>
+                <a:cs typeface="Consolas" panose="020B0609020204030204" pitchFamily="49" charset="0"/>
+              </a:rPr>
+              <a:t>Iprinter</a:t>
+            </a:r>
+            <a:r>
+              <a:rPr lang="en-US" sz="1400" dirty="0">
+                <a:latin typeface="Consolas" panose="020B0609020204030204" pitchFamily="49" charset="0"/>
+                <a:cs typeface="Consolas" panose="020B0609020204030204" pitchFamily="49" charset="0"/>
+              </a:rPr>
+              <a:t> {</a:t>
+            </a:r>
+            <a:br>
+              <a:rPr lang="en-US" sz="1400" dirty="0">
+                <a:latin typeface="Consolas" panose="020B0609020204030204" pitchFamily="49" charset="0"/>
+                <a:cs typeface="Consolas" panose="020B0609020204030204" pitchFamily="49" charset="0"/>
+              </a:rPr>
+            </a:br>
+            <a:r>
+              <a:rPr lang="en-US" sz="1400" dirty="0">
+                <a:latin typeface="Consolas" panose="020B0609020204030204" pitchFamily="49" charset="0"/>
+                <a:cs typeface="Consolas" panose="020B0609020204030204" pitchFamily="49" charset="0"/>
+              </a:rPr>
+              <a:t>    public void Print(string text) {</a:t>
+            </a:r>
+          </a:p>
+          <a:p>
+            <a:r>
+              <a:rPr lang="en-US" sz="1400" dirty="0">
+                <a:latin typeface="Consolas" panose="020B0609020204030204" pitchFamily="49" charset="0"/>
+                <a:cs typeface="Consolas" panose="020B0609020204030204" pitchFamily="49" charset="0"/>
+              </a:rPr>
+              <a:t>        var lines = </a:t>
+            </a:r>
+            <a:r>
+              <a:rPr lang="en-US" sz="1400" dirty="0" err="1">
+                <a:latin typeface="Consolas" panose="020B0609020204030204" pitchFamily="49" charset="0"/>
+                <a:cs typeface="Consolas" panose="020B0609020204030204" pitchFamily="49" charset="0"/>
+              </a:rPr>
+              <a:t>text.Split</a:t>
+            </a:r>
+            <a:r>
+              <a:rPr lang="en-US" sz="1400" dirty="0">
+                <a:latin typeface="Consolas" panose="020B0609020204030204" pitchFamily="49" charset="0"/>
+                <a:cs typeface="Consolas" panose="020B0609020204030204" pitchFamily="49" charset="0"/>
+              </a:rPr>
+              <a:t>("\n");</a:t>
+            </a:r>
+            <a:br>
+              <a:rPr lang="en-US" sz="1400" dirty="0">
+                <a:latin typeface="Consolas" panose="020B0609020204030204" pitchFamily="49" charset="0"/>
+                <a:cs typeface="Consolas" panose="020B0609020204030204" pitchFamily="49" charset="0"/>
+              </a:rPr>
+            </a:br>
+            <a:r>
+              <a:rPr lang="en-US" sz="1400" dirty="0">
+                <a:latin typeface="Consolas" panose="020B0609020204030204" pitchFamily="49" charset="0"/>
+                <a:cs typeface="Consolas" panose="020B0609020204030204" pitchFamily="49" charset="0"/>
+              </a:rPr>
+              <a:t>        foreach (var line in lines) {</a:t>
+            </a:r>
+            <a:br>
+              <a:rPr lang="en-US" sz="1400" dirty="0">
+                <a:latin typeface="Consolas" panose="020B0609020204030204" pitchFamily="49" charset="0"/>
+                <a:cs typeface="Consolas" panose="020B0609020204030204" pitchFamily="49" charset="0"/>
+              </a:rPr>
+            </a:br>
+            <a:r>
+              <a:rPr lang="en-US" sz="1400" dirty="0">
+                <a:latin typeface="Consolas" panose="020B0609020204030204" pitchFamily="49" charset="0"/>
+                <a:cs typeface="Consolas" panose="020B0609020204030204" pitchFamily="49" charset="0"/>
+              </a:rPr>
+              <a:t>            </a:t>
+            </a:r>
+            <a:r>
+              <a:rPr lang="en-US" sz="1400" i="1" dirty="0" err="1">
+                <a:latin typeface="Consolas" panose="020B0609020204030204" pitchFamily="49" charset="0"/>
+                <a:cs typeface="Consolas" panose="020B0609020204030204" pitchFamily="49" charset="0"/>
               </a:rPr>
               <a:t>printLine</a:t>
             </a:r>
             <a:r>
-              <a:rPr lang="da-DK" sz="1300" dirty="0">
-                <a:latin typeface="Consolas" pitchFamily="49" charset="0"/>
-                <a:cs typeface="Consolas" pitchFamily="49" charset="0"/>
-              </a:rPr>
-              <a:t>(l);</a:t>
-            </a:r>
-          </a:p>
-          <a:p>
-            <a:r>
-              <a:rPr lang="da-DK" sz="1300" dirty="0">
-                <a:latin typeface="Consolas" pitchFamily="49" charset="0"/>
-                <a:cs typeface="Consolas" pitchFamily="49" charset="0"/>
+              <a:rPr lang="en-US" sz="1400" i="1" dirty="0">
+                <a:latin typeface="Consolas" panose="020B0609020204030204" pitchFamily="49" charset="0"/>
+                <a:cs typeface="Consolas" panose="020B0609020204030204" pitchFamily="49" charset="0"/>
+              </a:rPr>
+              <a:t>(line);</a:t>
+            </a:r>
+            <a:br>
+              <a:rPr lang="en-US" sz="1400" i="1" dirty="0">
+                <a:latin typeface="Consolas" panose="020B0609020204030204" pitchFamily="49" charset="0"/>
+                <a:cs typeface="Consolas" panose="020B0609020204030204" pitchFamily="49" charset="0"/>
+              </a:rPr>
+            </a:br>
+            <a:r>
+              <a:rPr lang="en-US" sz="1400" i="1" dirty="0">
+                <a:latin typeface="Consolas" panose="020B0609020204030204" pitchFamily="49" charset="0"/>
+                <a:cs typeface="Consolas" panose="020B0609020204030204" pitchFamily="49" charset="0"/>
+              </a:rPr>
+              <a:t>        </a:t>
+            </a:r>
+            <a:r>
+              <a:rPr lang="en-US" sz="1400" dirty="0">
+                <a:latin typeface="Consolas" panose="020B0609020204030204" pitchFamily="49" charset="0"/>
+                <a:cs typeface="Consolas" panose="020B0609020204030204" pitchFamily="49" charset="0"/>
               </a:rPr>
               <a:t>}</a:t>
             </a:r>
-          </a:p>
-          <a:p>
-            <a:endParaRPr lang="da-DK" sz="1300" dirty="0">
-              <a:latin typeface="Consolas" pitchFamily="49" charset="0"/>
-              <a:cs typeface="Consolas" pitchFamily="49" charset="0"/>
-            </a:endParaRPr>
-          </a:p>
-          <a:p>
-            <a:r>
-              <a:rPr lang="da-DK" sz="1300" dirty="0" err="1">
-                <a:latin typeface="Consolas" pitchFamily="49" charset="0"/>
-                <a:cs typeface="Consolas" pitchFamily="49" charset="0"/>
-              </a:rPr>
-              <a:t>void</a:t>
-            </a:r>
-            <a:r>
-              <a:rPr lang="da-DK" sz="1300" dirty="0">
-                <a:latin typeface="Consolas" pitchFamily="49" charset="0"/>
-                <a:cs typeface="Consolas" pitchFamily="49" charset="0"/>
-              </a:rPr>
-              <a:t> </a:t>
-            </a:r>
-            <a:r>
-              <a:rPr lang="da-DK" sz="1300" dirty="0" err="1">
-                <a:latin typeface="Consolas" pitchFamily="49" charset="0"/>
-                <a:cs typeface="Consolas" pitchFamily="49" charset="0"/>
-              </a:rPr>
-              <a:t>TheNewPrinterDriver</a:t>
-            </a:r>
-            <a:r>
-              <a:rPr lang="da-DK" sz="1300" dirty="0">
-                <a:latin typeface="Consolas" pitchFamily="49" charset="0"/>
-                <a:cs typeface="Consolas" pitchFamily="49" charset="0"/>
-              </a:rPr>
-              <a:t>::</a:t>
-            </a:r>
-            <a:r>
-              <a:rPr lang="da-DK" sz="1300" dirty="0" err="1">
-                <a:latin typeface="Consolas" pitchFamily="49" charset="0"/>
-                <a:cs typeface="Consolas" pitchFamily="49" charset="0"/>
-              </a:rPr>
-              <a:t>printLine</a:t>
-            </a:r>
-            <a:r>
-              <a:rPr lang="da-DK" sz="1300" dirty="0">
-                <a:latin typeface="Consolas" pitchFamily="49" charset="0"/>
-                <a:cs typeface="Consolas" pitchFamily="49" charset="0"/>
-              </a:rPr>
-              <a:t>(line l)</a:t>
-            </a:r>
-          </a:p>
-          <a:p>
-            <a:r>
-              <a:rPr lang="da-DK" sz="1300" dirty="0">
-                <a:latin typeface="Consolas" pitchFamily="49" charset="0"/>
-                <a:cs typeface="Consolas" pitchFamily="49" charset="0"/>
-              </a:rPr>
-              <a:t>{</a:t>
-            </a:r>
-          </a:p>
-          <a:p>
-            <a:r>
-              <a:rPr lang="da-DK" sz="1300" dirty="0">
-                <a:latin typeface="Consolas" pitchFamily="49" charset="0"/>
-                <a:cs typeface="Consolas" pitchFamily="49" charset="0"/>
-              </a:rPr>
-              <a:t>  // </a:t>
-            </a:r>
-            <a:r>
-              <a:rPr lang="da-DK" sz="1300" dirty="0" err="1">
-                <a:latin typeface="Consolas" pitchFamily="49" charset="0"/>
-                <a:cs typeface="Consolas" pitchFamily="49" charset="0"/>
-              </a:rPr>
-              <a:t>Whatever</a:t>
-            </a:r>
-            <a:r>
-              <a:rPr lang="da-DK" sz="1300" dirty="0">
-                <a:latin typeface="Consolas" pitchFamily="49" charset="0"/>
-                <a:cs typeface="Consolas" pitchFamily="49" charset="0"/>
-              </a:rPr>
-              <a:t> it </a:t>
-            </a:r>
-            <a:r>
-              <a:rPr lang="da-DK" sz="1300" dirty="0" err="1">
-                <a:latin typeface="Consolas" pitchFamily="49" charset="0"/>
-                <a:cs typeface="Consolas" pitchFamily="49" charset="0"/>
-              </a:rPr>
-              <a:t>takes</a:t>
-            </a:r>
-            <a:r>
-              <a:rPr lang="da-DK" sz="1300" dirty="0">
-                <a:latin typeface="Consolas" pitchFamily="49" charset="0"/>
-                <a:cs typeface="Consolas" pitchFamily="49" charset="0"/>
-              </a:rPr>
-              <a:t> to put ‘l’ on </a:t>
-            </a:r>
-            <a:r>
-              <a:rPr lang="da-DK" sz="1300" dirty="0" err="1">
-                <a:latin typeface="Consolas" pitchFamily="49" charset="0"/>
-                <a:cs typeface="Consolas" pitchFamily="49" charset="0"/>
-              </a:rPr>
-              <a:t>paper</a:t>
-            </a:r>
-            <a:endParaRPr lang="da-DK" sz="1300" dirty="0">
-              <a:latin typeface="Consolas" pitchFamily="49" charset="0"/>
-              <a:cs typeface="Consolas" pitchFamily="49" charset="0"/>
-            </a:endParaRPr>
-          </a:p>
-          <a:p>
-            <a:r>
-              <a:rPr lang="da-DK" sz="1300" dirty="0">
-                <a:latin typeface="Consolas" pitchFamily="49" charset="0"/>
-                <a:cs typeface="Consolas" pitchFamily="49" charset="0"/>
+            <a:br>
+              <a:rPr lang="en-US" sz="1400" dirty="0">
+                <a:latin typeface="Consolas" panose="020B0609020204030204" pitchFamily="49" charset="0"/>
+                <a:cs typeface="Consolas" panose="020B0609020204030204" pitchFamily="49" charset="0"/>
+              </a:rPr>
+            </a:br>
+            <a:r>
+              <a:rPr lang="en-US" sz="1400" dirty="0">
+                <a:latin typeface="Consolas" panose="020B0609020204030204" pitchFamily="49" charset="0"/>
+                <a:cs typeface="Consolas" panose="020B0609020204030204" pitchFamily="49" charset="0"/>
+              </a:rPr>
+              <a:t>    }</a:t>
+            </a:r>
+            <a:br>
+              <a:rPr lang="en-US" sz="1400" dirty="0">
+                <a:latin typeface="Consolas" panose="020B0609020204030204" pitchFamily="49" charset="0"/>
+                <a:cs typeface="Consolas" panose="020B0609020204030204" pitchFamily="49" charset="0"/>
+              </a:rPr>
+            </a:br>
+            <a:r>
+              <a:rPr lang="en-US" sz="1400" dirty="0">
+                <a:latin typeface="Consolas" panose="020B0609020204030204" pitchFamily="49" charset="0"/>
+                <a:cs typeface="Consolas" panose="020B0609020204030204" pitchFamily="49" charset="0"/>
               </a:rPr>
               <a:t>}</a:t>
             </a:r>
@@ -9019,7 +8886,7 @@
         <p:spPr>
           <a:xfrm>
             <a:off x="4644008" y="5143020"/>
-            <a:ext cx="4022255" cy="892552"/>
+            <a:ext cx="3638858" cy="1169551"/>
           </a:xfrm>
           <a:prstGeom prst="rect">
             <a:avLst/>
@@ -9041,130 +8908,109 @@
           </a:effectLst>
         </p:spPr>
         <p:txBody>
-          <a:bodyPr wrap="none" rtlCol="0">
+          <a:bodyPr wrap="square" rtlCol="0">
             <a:spAutoFit/>
           </a:bodyPr>
           <a:lstStyle/>
           <a:p>
             <a:r>
-              <a:rPr lang="da-DK" sz="1300" dirty="0" err="1">
-                <a:latin typeface="Consolas" pitchFamily="49" charset="0"/>
-                <a:cs typeface="Consolas" pitchFamily="49" charset="0"/>
-              </a:rPr>
-              <a:t>void</a:t>
-            </a:r>
-            <a:r>
-              <a:rPr lang="da-DK" sz="1300" dirty="0">
-                <a:latin typeface="Consolas" pitchFamily="49" charset="0"/>
-                <a:cs typeface="Consolas" pitchFamily="49" charset="0"/>
-              </a:rPr>
-              <a:t> </a:t>
-            </a:r>
-            <a:r>
-              <a:rPr lang="da-DK" sz="1300" dirty="0" err="1">
-                <a:latin typeface="Consolas" pitchFamily="49" charset="0"/>
-                <a:cs typeface="Consolas" pitchFamily="49" charset="0"/>
-              </a:rPr>
-              <a:t>YeOlePrinter</a:t>
-            </a:r>
-            <a:r>
-              <a:rPr lang="da-DK" sz="1300" dirty="0">
-                <a:latin typeface="Consolas" pitchFamily="49" charset="0"/>
-                <a:cs typeface="Consolas" pitchFamily="49" charset="0"/>
-              </a:rPr>
-              <a:t>::</a:t>
-            </a:r>
-            <a:r>
-              <a:rPr lang="da-DK" sz="1300" dirty="0" err="1">
-                <a:latin typeface="Consolas" pitchFamily="49" charset="0"/>
-                <a:cs typeface="Consolas" pitchFamily="49" charset="0"/>
-              </a:rPr>
-              <a:t>printChar</a:t>
-            </a:r>
-            <a:r>
-              <a:rPr lang="da-DK" sz="1300" dirty="0">
-                <a:latin typeface="Consolas" pitchFamily="49" charset="0"/>
-                <a:cs typeface="Consolas" pitchFamily="49" charset="0"/>
-              </a:rPr>
-              <a:t>(</a:t>
-            </a:r>
-            <a:r>
-              <a:rPr lang="da-DK" sz="1300" dirty="0" err="1">
-                <a:latin typeface="Consolas" pitchFamily="49" charset="0"/>
-                <a:cs typeface="Consolas" pitchFamily="49" charset="0"/>
-              </a:rPr>
-              <a:t>char</a:t>
-            </a:r>
-            <a:r>
-              <a:rPr lang="da-DK" sz="1300" dirty="0">
-                <a:latin typeface="Consolas" pitchFamily="49" charset="0"/>
-                <a:cs typeface="Consolas" pitchFamily="49" charset="0"/>
-              </a:rPr>
-              <a:t> c)</a:t>
-            </a:r>
-          </a:p>
-          <a:p>
-            <a:r>
-              <a:rPr lang="da-DK" sz="1300" dirty="0">
-                <a:latin typeface="Consolas" pitchFamily="49" charset="0"/>
-                <a:cs typeface="Consolas" pitchFamily="49" charset="0"/>
-              </a:rPr>
-              <a:t>{</a:t>
-            </a:r>
-          </a:p>
-          <a:p>
-            <a:r>
-              <a:rPr lang="da-DK" sz="1300" dirty="0">
-                <a:latin typeface="Consolas" pitchFamily="49" charset="0"/>
-                <a:cs typeface="Consolas" pitchFamily="49" charset="0"/>
-              </a:rPr>
-              <a:t>  // </a:t>
-            </a:r>
-            <a:r>
-              <a:rPr lang="da-DK" sz="1300" dirty="0" err="1">
-                <a:latin typeface="Consolas" pitchFamily="49" charset="0"/>
-                <a:cs typeface="Consolas" pitchFamily="49" charset="0"/>
-              </a:rPr>
-              <a:t>Whatever</a:t>
-            </a:r>
-            <a:r>
-              <a:rPr lang="da-DK" sz="1300" dirty="0">
-                <a:latin typeface="Consolas" pitchFamily="49" charset="0"/>
-                <a:cs typeface="Consolas" pitchFamily="49" charset="0"/>
-              </a:rPr>
-              <a:t> it </a:t>
-            </a:r>
-            <a:r>
-              <a:rPr lang="da-DK" sz="1300" dirty="0" err="1">
-                <a:latin typeface="Consolas" pitchFamily="49" charset="0"/>
-                <a:cs typeface="Consolas" pitchFamily="49" charset="0"/>
-              </a:rPr>
-              <a:t>takes</a:t>
-            </a:r>
-            <a:r>
-              <a:rPr lang="da-DK" sz="1300" dirty="0">
-                <a:latin typeface="Consolas" pitchFamily="49" charset="0"/>
-                <a:cs typeface="Consolas" pitchFamily="49" charset="0"/>
-              </a:rPr>
-              <a:t> to put ‘c’ on </a:t>
-            </a:r>
-            <a:r>
-              <a:rPr lang="da-DK" sz="1300" dirty="0" err="1">
-                <a:latin typeface="Consolas" pitchFamily="49" charset="0"/>
-                <a:cs typeface="Consolas" pitchFamily="49" charset="0"/>
-              </a:rPr>
-              <a:t>paper</a:t>
-            </a:r>
-            <a:endParaRPr lang="da-DK" sz="1300" dirty="0">
-              <a:latin typeface="Consolas" pitchFamily="49" charset="0"/>
-              <a:cs typeface="Consolas" pitchFamily="49" charset="0"/>
-            </a:endParaRPr>
-          </a:p>
-          <a:p>
-            <a:r>
-              <a:rPr lang="da-DK" sz="1300" dirty="0">
-                <a:latin typeface="Consolas" pitchFamily="49" charset="0"/>
-                <a:cs typeface="Consolas" pitchFamily="49" charset="0"/>
+              <a:rPr lang="en-US" sz="1400" dirty="0">
+                <a:latin typeface="Consolas" panose="020B0609020204030204" pitchFamily="49" charset="0"/>
+                <a:cs typeface="Consolas" panose="020B0609020204030204" pitchFamily="49" charset="0"/>
+              </a:rPr>
+              <a:t>public class </a:t>
+            </a:r>
+            <a:r>
+              <a:rPr lang="en-US" sz="1400" dirty="0" err="1">
+                <a:latin typeface="Consolas" panose="020B0609020204030204" pitchFamily="49" charset="0"/>
+                <a:cs typeface="Consolas" panose="020B0609020204030204" pitchFamily="49" charset="0"/>
+              </a:rPr>
+              <a:t>YeOldPrinter</a:t>
+            </a:r>
+            <a:r>
+              <a:rPr lang="en-US" sz="1400" dirty="0">
+                <a:latin typeface="Consolas" panose="020B0609020204030204" pitchFamily="49" charset="0"/>
+                <a:cs typeface="Consolas" panose="020B0609020204030204" pitchFamily="49" charset="0"/>
+              </a:rPr>
+              <a:t> {</a:t>
+            </a:r>
+            <a:br>
+              <a:rPr lang="en-US" sz="1400" dirty="0">
+                <a:latin typeface="Consolas" panose="020B0609020204030204" pitchFamily="49" charset="0"/>
+                <a:cs typeface="Consolas" panose="020B0609020204030204" pitchFamily="49" charset="0"/>
+              </a:rPr>
+            </a:br>
+            <a:r>
+              <a:rPr lang="en-US" sz="1400" dirty="0">
+                <a:latin typeface="Consolas" panose="020B0609020204030204" pitchFamily="49" charset="0"/>
+                <a:cs typeface="Consolas" panose="020B0609020204030204" pitchFamily="49" charset="0"/>
+              </a:rPr>
+              <a:t>    public void </a:t>
+            </a:r>
+            <a:r>
+              <a:rPr lang="en-US" sz="1400" dirty="0" err="1">
+                <a:latin typeface="Consolas" panose="020B0609020204030204" pitchFamily="49" charset="0"/>
+                <a:cs typeface="Consolas" panose="020B0609020204030204" pitchFamily="49" charset="0"/>
+              </a:rPr>
+              <a:t>PrintChar</a:t>
+            </a:r>
+            <a:r>
+              <a:rPr lang="en-US" sz="1400" dirty="0">
+                <a:latin typeface="Consolas" panose="020B0609020204030204" pitchFamily="49" charset="0"/>
+                <a:cs typeface="Consolas" panose="020B0609020204030204" pitchFamily="49" charset="0"/>
+              </a:rPr>
+              <a:t>(char c) {</a:t>
+            </a:r>
+            <a:br>
+              <a:rPr lang="en-US" sz="1400" dirty="0">
+                <a:latin typeface="Consolas" panose="020B0609020204030204" pitchFamily="49" charset="0"/>
+                <a:cs typeface="Consolas" panose="020B0609020204030204" pitchFamily="49" charset="0"/>
+              </a:rPr>
+            </a:br>
+            <a:r>
+              <a:rPr lang="en-US" sz="1400" dirty="0">
+                <a:latin typeface="Consolas" panose="020B0609020204030204" pitchFamily="49" charset="0"/>
+                <a:cs typeface="Consolas" panose="020B0609020204030204" pitchFamily="49" charset="0"/>
+              </a:rPr>
+              <a:t>        </a:t>
+            </a:r>
+            <a:r>
+              <a:rPr lang="en-US" sz="1400" i="1" dirty="0">
+                <a:latin typeface="Consolas" panose="020B0609020204030204" pitchFamily="49" charset="0"/>
+                <a:cs typeface="Consolas" panose="020B0609020204030204" pitchFamily="49" charset="0"/>
+              </a:rPr>
+              <a:t>// .. print c on paper</a:t>
+            </a:r>
+            <a:br>
+              <a:rPr lang="en-US" sz="1400" i="1" dirty="0">
+                <a:latin typeface="Consolas" panose="020B0609020204030204" pitchFamily="49" charset="0"/>
+                <a:cs typeface="Consolas" panose="020B0609020204030204" pitchFamily="49" charset="0"/>
+              </a:rPr>
+            </a:br>
+            <a:r>
+              <a:rPr lang="en-US" sz="1400" i="1" dirty="0">
+                <a:latin typeface="Consolas" panose="020B0609020204030204" pitchFamily="49" charset="0"/>
+                <a:cs typeface="Consolas" panose="020B0609020204030204" pitchFamily="49" charset="0"/>
+              </a:rPr>
+              <a:t>    </a:t>
+            </a:r>
+            <a:r>
+              <a:rPr lang="en-US" sz="1400" dirty="0">
+                <a:latin typeface="Consolas" panose="020B0609020204030204" pitchFamily="49" charset="0"/>
+                <a:cs typeface="Consolas" panose="020B0609020204030204" pitchFamily="49" charset="0"/>
+              </a:rPr>
+              <a:t>}</a:t>
+            </a:r>
+            <a:br>
+              <a:rPr lang="en-US" sz="1400" dirty="0">
+                <a:latin typeface="Consolas" panose="020B0609020204030204" pitchFamily="49" charset="0"/>
+                <a:cs typeface="Consolas" panose="020B0609020204030204" pitchFamily="49" charset="0"/>
+              </a:rPr>
+            </a:br>
+            <a:r>
+              <a:rPr lang="en-US" sz="1400" dirty="0">
+                <a:latin typeface="Consolas" panose="020B0609020204030204" pitchFamily="49" charset="0"/>
+                <a:cs typeface="Consolas" panose="020B0609020204030204" pitchFamily="49" charset="0"/>
               </a:rPr>
               <a:t>}</a:t>
             </a:r>
@@ -9208,6 +9054,7 @@
         <p:nvCxnSpPr>
           <p:cNvPr id="12" name="Straight Arrow Connector 11"/>
           <p:cNvCxnSpPr>
+            <a:cxnSpLocks/>
             <a:stCxn id="11" idx="0"/>
           </p:cNvCxnSpPr>
           <p:nvPr/>
@@ -9215,7 +9062,7 @@
         <p:spPr>
           <a:xfrm flipH="1" flipV="1">
             <a:off x="5788025" y="3645024"/>
-            <a:ext cx="867111" cy="1497996"/>
+            <a:ext cx="675412" cy="1497996"/>
           </a:xfrm>
           <a:prstGeom prst="straightConnector1">
             <a:avLst/>
@@ -9407,8 +9254,8 @@
         </p:nvSpPr>
         <p:spPr>
           <a:xfrm>
-            <a:off x="479779" y="4542855"/>
-            <a:ext cx="3565400" cy="2092881"/>
+            <a:off x="477737" y="4352618"/>
+            <a:ext cx="4022256" cy="2246769"/>
           </a:xfrm>
           <a:prstGeom prst="rect">
             <a:avLst/>
@@ -9436,213 +9283,196 @@
           <a:lstStyle/>
           <a:p>
             <a:r>
-              <a:rPr lang="da-DK" sz="1300" dirty="0" err="1">
-                <a:latin typeface="Consolas" pitchFamily="49" charset="0"/>
-                <a:cs typeface="Consolas" pitchFamily="49" charset="0"/>
+              <a:rPr lang="en-US" sz="1400" dirty="0">
+                <a:latin typeface="Consolas" panose="020B0609020204030204" pitchFamily="49" charset="0"/>
+                <a:cs typeface="Consolas" panose="020B0609020204030204" pitchFamily="49" charset="0"/>
+              </a:rPr>
+              <a:t>public class </a:t>
+            </a:r>
+            <a:r>
+              <a:rPr lang="en-US" sz="1400" dirty="0" err="1">
+                <a:latin typeface="Consolas" panose="020B0609020204030204" pitchFamily="49" charset="0"/>
+                <a:cs typeface="Consolas" panose="020B0609020204030204" pitchFamily="49" charset="0"/>
               </a:rPr>
               <a:t>TextEditor</a:t>
             </a:r>
             <a:r>
-              <a:rPr lang="da-DK" sz="1300" dirty="0">
-                <a:latin typeface="Consolas" pitchFamily="49" charset="0"/>
-                <a:cs typeface="Consolas" pitchFamily="49" charset="0"/>
-              </a:rPr>
-              <a:t>::</a:t>
-            </a:r>
-            <a:r>
-              <a:rPr lang="da-DK" sz="1300" dirty="0" err="1">
-                <a:latin typeface="Consolas" pitchFamily="49" charset="0"/>
-                <a:cs typeface="Consolas" pitchFamily="49" charset="0"/>
+              <a:rPr lang="en-US" sz="1400" dirty="0">
+                <a:latin typeface="Consolas" panose="020B0609020204030204" pitchFamily="49" charset="0"/>
+                <a:cs typeface="Consolas" panose="020B0609020204030204" pitchFamily="49" charset="0"/>
+              </a:rPr>
+              <a:t> {</a:t>
+            </a:r>
+            <a:br>
+              <a:rPr lang="en-US" sz="1400" dirty="0">
+                <a:latin typeface="Consolas" panose="020B0609020204030204" pitchFamily="49" charset="0"/>
+                <a:cs typeface="Consolas" panose="020B0609020204030204" pitchFamily="49" charset="0"/>
+              </a:rPr>
+            </a:br>
+            <a:r>
+              <a:rPr lang="en-US" sz="1400" dirty="0">
+                <a:latin typeface="Consolas" panose="020B0609020204030204" pitchFamily="49" charset="0"/>
+                <a:cs typeface="Consolas" panose="020B0609020204030204" pitchFamily="49" charset="0"/>
+              </a:rPr>
+              <a:t>    public </a:t>
+            </a:r>
+            <a:r>
+              <a:rPr lang="en-US" sz="1400" dirty="0" err="1">
+                <a:latin typeface="Consolas" panose="020B0609020204030204" pitchFamily="49" charset="0"/>
+                <a:cs typeface="Consolas" panose="020B0609020204030204" pitchFamily="49" charset="0"/>
               </a:rPr>
               <a:t>TextEditor</a:t>
             </a:r>
             <a:r>
-              <a:rPr lang="da-DK" sz="1300" dirty="0">
-                <a:latin typeface="Consolas" pitchFamily="49" charset="0"/>
-                <a:cs typeface="Consolas" pitchFamily="49" charset="0"/>
-              </a:rPr>
-              <a:t>()</a:t>
-            </a:r>
-          </a:p>
-          <a:p>
-            <a:r>
-              <a:rPr lang="da-DK" sz="1300" dirty="0">
-                <a:latin typeface="Consolas" pitchFamily="49" charset="0"/>
-                <a:cs typeface="Consolas" pitchFamily="49" charset="0"/>
-              </a:rPr>
-              <a:t>{</a:t>
-            </a:r>
-          </a:p>
-          <a:p>
-            <a:r>
-              <a:rPr lang="da-DK" sz="1300" dirty="0">
-                <a:latin typeface="Consolas" pitchFamily="49" charset="0"/>
-                <a:cs typeface="Consolas" pitchFamily="49" charset="0"/>
-              </a:rPr>
-              <a:t>  printer = new </a:t>
-            </a:r>
-            <a:r>
-              <a:rPr lang="da-DK" sz="1300" dirty="0" err="1">
-                <a:latin typeface="Consolas" pitchFamily="49" charset="0"/>
-                <a:cs typeface="Consolas" pitchFamily="49" charset="0"/>
-              </a:rPr>
-              <a:t>YeOlePrinter</a:t>
-            </a:r>
-            <a:r>
-              <a:rPr lang="da-DK" sz="1300" dirty="0">
-                <a:latin typeface="Consolas" pitchFamily="49" charset="0"/>
-                <a:cs typeface="Consolas" pitchFamily="49" charset="0"/>
-              </a:rPr>
-              <a:t>()</a:t>
-            </a:r>
-          </a:p>
-          <a:p>
-            <a:r>
-              <a:rPr lang="da-DK" sz="1300" dirty="0">
-                <a:latin typeface="Consolas" pitchFamily="49" charset="0"/>
-                <a:cs typeface="Consolas" pitchFamily="49" charset="0"/>
-              </a:rPr>
-              <a:t>}</a:t>
-            </a:r>
-          </a:p>
-          <a:p>
-            <a:endParaRPr lang="da-DK" sz="1300" dirty="0">
-              <a:latin typeface="Consolas" pitchFamily="49" charset="0"/>
-              <a:cs typeface="Consolas" pitchFamily="49" charset="0"/>
-            </a:endParaRPr>
-          </a:p>
-          <a:p>
-            <a:r>
-              <a:rPr lang="da-DK" sz="1300" dirty="0" err="1">
-                <a:latin typeface="Consolas" pitchFamily="49" charset="0"/>
-                <a:cs typeface="Consolas" pitchFamily="49" charset="0"/>
-              </a:rPr>
-              <a:t>void</a:t>
-            </a:r>
-            <a:r>
-              <a:rPr lang="da-DK" sz="1300" dirty="0">
-                <a:latin typeface="Consolas" pitchFamily="49" charset="0"/>
-                <a:cs typeface="Consolas" pitchFamily="49" charset="0"/>
-              </a:rPr>
-              <a:t> </a:t>
-            </a:r>
-            <a:r>
-              <a:rPr lang="da-DK" sz="1300" dirty="0" err="1">
-                <a:latin typeface="Consolas" pitchFamily="49" charset="0"/>
-                <a:cs typeface="Consolas" pitchFamily="49" charset="0"/>
-              </a:rPr>
-              <a:t>TextEditor</a:t>
-            </a:r>
-            <a:r>
-              <a:rPr lang="da-DK" sz="1300" dirty="0">
-                <a:latin typeface="Consolas" pitchFamily="49" charset="0"/>
-                <a:cs typeface="Consolas" pitchFamily="49" charset="0"/>
-              </a:rPr>
-              <a:t>::</a:t>
-            </a:r>
-            <a:r>
-              <a:rPr lang="da-DK" sz="1300" dirty="0" err="1">
-                <a:latin typeface="Consolas" pitchFamily="49" charset="0"/>
-                <a:cs typeface="Consolas" pitchFamily="49" charset="0"/>
-              </a:rPr>
-              <a:t>OnButtonPrint</a:t>
-            </a:r>
-            <a:r>
-              <a:rPr lang="da-DK" sz="1300" dirty="0">
-                <a:latin typeface="Consolas" pitchFamily="49" charset="0"/>
-                <a:cs typeface="Consolas" pitchFamily="49" charset="0"/>
-              </a:rPr>
-              <a:t>()</a:t>
-            </a:r>
-          </a:p>
-          <a:p>
-            <a:r>
-              <a:rPr lang="da-DK" sz="1300" dirty="0">
-                <a:latin typeface="Consolas" pitchFamily="49" charset="0"/>
-                <a:cs typeface="Consolas" pitchFamily="49" charset="0"/>
-              </a:rPr>
-              <a:t>{</a:t>
-            </a:r>
-          </a:p>
-          <a:p>
-            <a:r>
-              <a:rPr lang="da-DK" sz="1300" dirty="0">
-                <a:latin typeface="Consolas" pitchFamily="49" charset="0"/>
-                <a:cs typeface="Consolas" pitchFamily="49" charset="0"/>
-              </a:rPr>
-              <a:t>  for </a:t>
-            </a:r>
-            <a:r>
-              <a:rPr lang="da-DK" sz="1300" dirty="0" err="1">
-                <a:latin typeface="Consolas" pitchFamily="49" charset="0"/>
-                <a:cs typeface="Consolas" pitchFamily="49" charset="0"/>
-              </a:rPr>
-              <a:t>each</a:t>
-            </a:r>
-            <a:r>
-              <a:rPr lang="da-DK" sz="1300" dirty="0">
-                <a:latin typeface="Consolas" pitchFamily="49" charset="0"/>
-                <a:cs typeface="Consolas" pitchFamily="49" charset="0"/>
-              </a:rPr>
-              <a:t> </a:t>
-            </a:r>
-            <a:r>
-              <a:rPr lang="da-DK" sz="1300" dirty="0" err="1">
-                <a:latin typeface="Consolas" pitchFamily="49" charset="0"/>
-                <a:cs typeface="Consolas" pitchFamily="49" charset="0"/>
-              </a:rPr>
-              <a:t>char</a:t>
-            </a:r>
-            <a:r>
-              <a:rPr lang="da-DK" sz="1300" dirty="0">
-                <a:latin typeface="Consolas" pitchFamily="49" charset="0"/>
-                <a:cs typeface="Consolas" pitchFamily="49" charset="0"/>
-              </a:rPr>
-              <a:t> c in </a:t>
-            </a:r>
-            <a:r>
-              <a:rPr lang="da-DK" sz="1300" dirty="0" err="1">
-                <a:latin typeface="Consolas" pitchFamily="49" charset="0"/>
-                <a:cs typeface="Consolas" pitchFamily="49" charset="0"/>
-              </a:rPr>
-              <a:t>currentText</a:t>
-            </a:r>
-            <a:r>
-              <a:rPr lang="da-DK" sz="1300" dirty="0">
-                <a:latin typeface="Consolas" pitchFamily="49" charset="0"/>
-                <a:cs typeface="Consolas" pitchFamily="49" charset="0"/>
-              </a:rPr>
-              <a:t>:</a:t>
-            </a:r>
-          </a:p>
-          <a:p>
-            <a:r>
-              <a:rPr lang="da-DK" sz="1300" dirty="0">
-                <a:latin typeface="Consolas" pitchFamily="49" charset="0"/>
-                <a:cs typeface="Consolas" pitchFamily="49" charset="0"/>
-              </a:rPr>
-              <a:t>    </a:t>
-            </a:r>
-            <a:r>
-              <a:rPr lang="da-DK" sz="1300" dirty="0" err="1">
-                <a:latin typeface="Consolas" pitchFamily="49" charset="0"/>
-                <a:cs typeface="Consolas" pitchFamily="49" charset="0"/>
-              </a:rPr>
-              <a:t>printer.printChar</a:t>
-            </a:r>
-            <a:r>
-              <a:rPr lang="da-DK" sz="1300" dirty="0">
-                <a:latin typeface="Consolas" pitchFamily="49" charset="0"/>
-                <a:cs typeface="Consolas" pitchFamily="49" charset="0"/>
-              </a:rPr>
-              <a:t>(c)</a:t>
-            </a:r>
-          </a:p>
-          <a:p>
-            <a:r>
-              <a:rPr lang="da-DK" sz="1300" dirty="0">
-                <a:latin typeface="Consolas" pitchFamily="49" charset="0"/>
-                <a:cs typeface="Consolas" pitchFamily="49" charset="0"/>
+              <a:rPr lang="en-US" sz="1400" dirty="0">
+                <a:latin typeface="Consolas" panose="020B0609020204030204" pitchFamily="49" charset="0"/>
+                <a:cs typeface="Consolas" panose="020B0609020204030204" pitchFamily="49" charset="0"/>
+              </a:rPr>
+              <a:t>() {</a:t>
+            </a:r>
+            <a:br>
+              <a:rPr lang="en-US" sz="1400" dirty="0">
+                <a:latin typeface="Consolas" panose="020B0609020204030204" pitchFamily="49" charset="0"/>
+                <a:cs typeface="Consolas" panose="020B0609020204030204" pitchFamily="49" charset="0"/>
+              </a:rPr>
+            </a:br>
+            <a:r>
+              <a:rPr lang="en-US" sz="1400" dirty="0">
+                <a:latin typeface="Consolas" panose="020B0609020204030204" pitchFamily="49" charset="0"/>
+                <a:cs typeface="Consolas" panose="020B0609020204030204" pitchFamily="49" charset="0"/>
+              </a:rPr>
+              <a:t>        _printer = new </a:t>
+            </a:r>
+            <a:r>
+              <a:rPr lang="en-US" sz="1400" dirty="0" err="1">
+                <a:latin typeface="Consolas" panose="020B0609020204030204" pitchFamily="49" charset="0"/>
+                <a:cs typeface="Consolas" panose="020B0609020204030204" pitchFamily="49" charset="0"/>
+              </a:rPr>
+              <a:t>YeOldPrinter</a:t>
+            </a:r>
+            <a:r>
+              <a:rPr lang="en-US" sz="1400" dirty="0">
+                <a:latin typeface="Consolas" panose="020B0609020204030204" pitchFamily="49" charset="0"/>
+                <a:cs typeface="Consolas" panose="020B0609020204030204" pitchFamily="49" charset="0"/>
+              </a:rPr>
+              <a:t>();</a:t>
+            </a:r>
+            <a:br>
+              <a:rPr lang="en-US" sz="1400" dirty="0">
+                <a:latin typeface="Consolas" panose="020B0609020204030204" pitchFamily="49" charset="0"/>
+                <a:cs typeface="Consolas" panose="020B0609020204030204" pitchFamily="49" charset="0"/>
+              </a:rPr>
+            </a:br>
+            <a:r>
+              <a:rPr lang="en-US" sz="1400" dirty="0">
+                <a:latin typeface="Consolas" panose="020B0609020204030204" pitchFamily="49" charset="0"/>
+                <a:cs typeface="Consolas" panose="020B0609020204030204" pitchFamily="49" charset="0"/>
+              </a:rPr>
+              <a:t>    }</a:t>
+            </a:r>
+            <a:br>
+              <a:rPr lang="en-US" sz="1400" dirty="0">
+                <a:latin typeface="Consolas" panose="020B0609020204030204" pitchFamily="49" charset="0"/>
+                <a:cs typeface="Consolas" panose="020B0609020204030204" pitchFamily="49" charset="0"/>
+              </a:rPr>
+            </a:br>
+            <a:r>
+              <a:rPr lang="en-US" sz="1400" dirty="0">
+                <a:latin typeface="Consolas" panose="020B0609020204030204" pitchFamily="49" charset="0"/>
+                <a:cs typeface="Consolas" panose="020B0609020204030204" pitchFamily="49" charset="0"/>
+              </a:rPr>
+              <a:t>    public void </a:t>
+            </a:r>
+            <a:r>
+              <a:rPr lang="en-US" sz="1400" dirty="0" err="1">
+                <a:latin typeface="Consolas" panose="020B0609020204030204" pitchFamily="49" charset="0"/>
+                <a:cs typeface="Consolas" panose="020B0609020204030204" pitchFamily="49" charset="0"/>
+              </a:rPr>
+              <a:t>OnPrintButton</a:t>
+            </a:r>
+            <a:r>
+              <a:rPr lang="en-US" sz="1400" dirty="0">
+                <a:latin typeface="Consolas" panose="020B0609020204030204" pitchFamily="49" charset="0"/>
+                <a:cs typeface="Consolas" panose="020B0609020204030204" pitchFamily="49" charset="0"/>
+              </a:rPr>
+              <a:t>() {</a:t>
+            </a:r>
+            <a:br>
+              <a:rPr lang="en-US" sz="1400" dirty="0">
+                <a:latin typeface="Consolas" panose="020B0609020204030204" pitchFamily="49" charset="0"/>
+                <a:cs typeface="Consolas" panose="020B0609020204030204" pitchFamily="49" charset="0"/>
+              </a:rPr>
+            </a:br>
+            <a:r>
+              <a:rPr lang="en-US" sz="1400" dirty="0">
+                <a:latin typeface="Consolas" panose="020B0609020204030204" pitchFamily="49" charset="0"/>
+                <a:cs typeface="Consolas" panose="020B0609020204030204" pitchFamily="49" charset="0"/>
+              </a:rPr>
+              <a:t>        foreach (char c in text) {</a:t>
+            </a:r>
+            <a:br>
+              <a:rPr lang="en-US" sz="1400" dirty="0">
+                <a:latin typeface="Consolas" panose="020B0609020204030204" pitchFamily="49" charset="0"/>
+                <a:cs typeface="Consolas" panose="020B0609020204030204" pitchFamily="49" charset="0"/>
+              </a:rPr>
+            </a:br>
+            <a:r>
+              <a:rPr lang="en-US" sz="1400" dirty="0">
+                <a:latin typeface="Consolas" panose="020B0609020204030204" pitchFamily="49" charset="0"/>
+                <a:cs typeface="Consolas" panose="020B0609020204030204" pitchFamily="49" charset="0"/>
+              </a:rPr>
+              <a:t>            _</a:t>
+            </a:r>
+            <a:r>
+              <a:rPr lang="en-US" sz="1400" dirty="0" err="1">
+                <a:latin typeface="Consolas" panose="020B0609020204030204" pitchFamily="49" charset="0"/>
+                <a:cs typeface="Consolas" panose="020B0609020204030204" pitchFamily="49" charset="0"/>
+              </a:rPr>
+              <a:t>printer.PrintChar</a:t>
+            </a:r>
+            <a:r>
+              <a:rPr lang="en-US" sz="1400" dirty="0">
+                <a:latin typeface="Consolas" panose="020B0609020204030204" pitchFamily="49" charset="0"/>
+                <a:cs typeface="Consolas" panose="020B0609020204030204" pitchFamily="49" charset="0"/>
+              </a:rPr>
+              <a:t>(c);</a:t>
+            </a:r>
+            <a:br>
+              <a:rPr lang="en-US" sz="1400" dirty="0">
+                <a:latin typeface="Consolas" panose="020B0609020204030204" pitchFamily="49" charset="0"/>
+                <a:cs typeface="Consolas" panose="020B0609020204030204" pitchFamily="49" charset="0"/>
+              </a:rPr>
+            </a:br>
+            <a:r>
+              <a:rPr lang="en-US" sz="1400" dirty="0">
+                <a:latin typeface="Consolas" panose="020B0609020204030204" pitchFamily="49" charset="0"/>
+                <a:cs typeface="Consolas" panose="020B0609020204030204" pitchFamily="49" charset="0"/>
+              </a:rPr>
+              <a:t>        }</a:t>
+            </a:r>
+            <a:br>
+              <a:rPr lang="en-US" sz="1400" dirty="0">
+                <a:latin typeface="Consolas" panose="020B0609020204030204" pitchFamily="49" charset="0"/>
+                <a:cs typeface="Consolas" panose="020B0609020204030204" pitchFamily="49" charset="0"/>
+              </a:rPr>
+            </a:br>
+            <a:r>
+              <a:rPr lang="en-US" sz="1400" dirty="0">
+                <a:latin typeface="Consolas" panose="020B0609020204030204" pitchFamily="49" charset="0"/>
+                <a:cs typeface="Consolas" panose="020B0609020204030204" pitchFamily="49" charset="0"/>
+              </a:rPr>
+              <a:t>    }</a:t>
+            </a:r>
+            <a:br>
+              <a:rPr lang="en-US" sz="1400" dirty="0">
+                <a:latin typeface="Consolas" panose="020B0609020204030204" pitchFamily="49" charset="0"/>
+                <a:cs typeface="Consolas" panose="020B0609020204030204" pitchFamily="49" charset="0"/>
+              </a:rPr>
+            </a:br>
+            <a:r>
+              <a:rPr lang="en-US" sz="1400" dirty="0">
+                <a:latin typeface="Consolas" panose="020B0609020204030204" pitchFamily="49" charset="0"/>
+                <a:cs typeface="Consolas" panose="020B0609020204030204" pitchFamily="49" charset="0"/>
               </a:rPr>
               <a:t>}</a:t>
             </a:r>
@@ -9953,8 +9783,8 @@
         </p:nvSpPr>
         <p:spPr>
           <a:xfrm>
-            <a:off x="4644008" y="5143020"/>
-            <a:ext cx="4113627" cy="892552"/>
+            <a:off x="4649650" y="5170993"/>
+            <a:ext cx="3960439" cy="1169551"/>
           </a:xfrm>
           <a:prstGeom prst="rect">
             <a:avLst/>
@@ -9976,171 +9806,115 @@
           </a:effectLst>
         </p:spPr>
         <p:txBody>
-          <a:bodyPr wrap="none" rtlCol="0">
+          <a:bodyPr wrap="square" rtlCol="0">
             <a:spAutoFit/>
           </a:bodyPr>
           <a:lstStyle/>
           <a:p>
             <a:r>
-              <a:rPr lang="da-DK" sz="1300" dirty="0" err="1">
-                <a:latin typeface="Consolas" pitchFamily="49" charset="0"/>
-                <a:cs typeface="Consolas" pitchFamily="49" charset="0"/>
-              </a:rPr>
-              <a:t>void</a:t>
-            </a:r>
-            <a:r>
-              <a:rPr lang="da-DK" sz="1300" dirty="0">
-                <a:latin typeface="Consolas" pitchFamily="49" charset="0"/>
-                <a:cs typeface="Consolas" pitchFamily="49" charset="0"/>
-              </a:rPr>
-              <a:t> </a:t>
-            </a:r>
-            <a:r>
-              <a:rPr lang="da-DK" sz="1300" dirty="0" err="1">
-                <a:latin typeface="Consolas" pitchFamily="49" charset="0"/>
-                <a:cs typeface="Consolas" pitchFamily="49" charset="0"/>
+              <a:rPr lang="en-US" sz="1400" dirty="0">
+                <a:latin typeface="Consolas" panose="020B0609020204030204" pitchFamily="49" charset="0"/>
+                <a:cs typeface="Consolas" panose="020B0609020204030204" pitchFamily="49" charset="0"/>
+              </a:rPr>
+              <a:t>public class </a:t>
+            </a:r>
+            <a:r>
+              <a:rPr lang="en-US" sz="1400" dirty="0" err="1">
+                <a:latin typeface="Consolas" panose="020B0609020204030204" pitchFamily="49" charset="0"/>
+                <a:cs typeface="Consolas" panose="020B0609020204030204" pitchFamily="49" charset="0"/>
               </a:rPr>
               <a:t>TheNewPrinter</a:t>
             </a:r>
             <a:r>
-              <a:rPr lang="da-DK" sz="1300" dirty="0">
-                <a:latin typeface="Consolas" pitchFamily="49" charset="0"/>
-                <a:cs typeface="Consolas" pitchFamily="49" charset="0"/>
-              </a:rPr>
-              <a:t>::</a:t>
-            </a:r>
-            <a:r>
-              <a:rPr lang="da-DK" sz="1300" dirty="0" err="1">
-                <a:latin typeface="Consolas" pitchFamily="49" charset="0"/>
-                <a:cs typeface="Consolas" pitchFamily="49" charset="0"/>
-              </a:rPr>
-              <a:t>printLine</a:t>
-            </a:r>
-            <a:r>
-              <a:rPr lang="da-DK" sz="1300" dirty="0">
-                <a:latin typeface="Consolas" pitchFamily="49" charset="0"/>
-                <a:cs typeface="Consolas" pitchFamily="49" charset="0"/>
-              </a:rPr>
-              <a:t>(</a:t>
-            </a:r>
-            <a:r>
-              <a:rPr lang="da-DK" sz="1300" dirty="0" err="1">
-                <a:latin typeface="Consolas" pitchFamily="49" charset="0"/>
-                <a:cs typeface="Consolas" pitchFamily="49" charset="0"/>
-              </a:rPr>
-              <a:t>char</a:t>
-            </a:r>
-            <a:r>
-              <a:rPr lang="da-DK" sz="1300" dirty="0">
-                <a:latin typeface="Consolas" pitchFamily="49" charset="0"/>
-                <a:cs typeface="Consolas" pitchFamily="49" charset="0"/>
-              </a:rPr>
-              <a:t> l)</a:t>
-            </a:r>
-          </a:p>
-          <a:p>
-            <a:r>
-              <a:rPr lang="da-DK" sz="1300" dirty="0">
-                <a:latin typeface="Consolas" pitchFamily="49" charset="0"/>
-                <a:cs typeface="Consolas" pitchFamily="49" charset="0"/>
-              </a:rPr>
-              <a:t>{</a:t>
-            </a:r>
-          </a:p>
-          <a:p>
-            <a:r>
-              <a:rPr lang="da-DK" sz="1300" dirty="0">
-                <a:latin typeface="Consolas" pitchFamily="49" charset="0"/>
-                <a:cs typeface="Consolas" pitchFamily="49" charset="0"/>
-              </a:rPr>
-              <a:t>  // </a:t>
-            </a:r>
-            <a:r>
-              <a:rPr lang="da-DK" sz="1300" dirty="0" err="1">
-                <a:latin typeface="Consolas" pitchFamily="49" charset="0"/>
-                <a:cs typeface="Consolas" pitchFamily="49" charset="0"/>
-              </a:rPr>
-              <a:t>Whatever</a:t>
-            </a:r>
-            <a:r>
-              <a:rPr lang="da-DK" sz="1300" dirty="0">
-                <a:latin typeface="Consolas" pitchFamily="49" charset="0"/>
-                <a:cs typeface="Consolas" pitchFamily="49" charset="0"/>
-              </a:rPr>
-              <a:t> it </a:t>
-            </a:r>
-            <a:r>
-              <a:rPr lang="da-DK" sz="1300" dirty="0" err="1">
-                <a:latin typeface="Consolas" pitchFamily="49" charset="0"/>
-                <a:cs typeface="Consolas" pitchFamily="49" charset="0"/>
-              </a:rPr>
-              <a:t>takes</a:t>
-            </a:r>
-            <a:r>
-              <a:rPr lang="da-DK" sz="1300" dirty="0">
-                <a:latin typeface="Consolas" pitchFamily="49" charset="0"/>
-                <a:cs typeface="Consolas" pitchFamily="49" charset="0"/>
-              </a:rPr>
-              <a:t> to put ‘l’ on </a:t>
-            </a:r>
-            <a:r>
-              <a:rPr lang="da-DK" sz="1300" dirty="0" err="1">
-                <a:latin typeface="Consolas" pitchFamily="49" charset="0"/>
-                <a:cs typeface="Consolas" pitchFamily="49" charset="0"/>
-              </a:rPr>
-              <a:t>paper</a:t>
-            </a:r>
-            <a:endParaRPr lang="da-DK" sz="1300" dirty="0">
-              <a:latin typeface="Consolas" pitchFamily="49" charset="0"/>
-              <a:cs typeface="Consolas" pitchFamily="49" charset="0"/>
-            </a:endParaRPr>
-          </a:p>
-          <a:p>
-            <a:r>
-              <a:rPr lang="da-DK" sz="1300" dirty="0">
-                <a:latin typeface="Consolas" pitchFamily="49" charset="0"/>
-                <a:cs typeface="Consolas" pitchFamily="49" charset="0"/>
+              <a:rPr lang="en-US" sz="1400" dirty="0">
+                <a:latin typeface="Consolas" panose="020B0609020204030204" pitchFamily="49" charset="0"/>
+                <a:cs typeface="Consolas" panose="020B0609020204030204" pitchFamily="49" charset="0"/>
+              </a:rPr>
+              <a:t> {</a:t>
+            </a:r>
+            <a:br>
+              <a:rPr lang="en-US" sz="1400" dirty="0">
+                <a:latin typeface="Consolas" panose="020B0609020204030204" pitchFamily="49" charset="0"/>
+                <a:cs typeface="Consolas" panose="020B0609020204030204" pitchFamily="49" charset="0"/>
+              </a:rPr>
+            </a:br>
+            <a:r>
+              <a:rPr lang="en-US" sz="1400" dirty="0">
+                <a:latin typeface="Consolas" panose="020B0609020204030204" pitchFamily="49" charset="0"/>
+                <a:cs typeface="Consolas" panose="020B0609020204030204" pitchFamily="49" charset="0"/>
+              </a:rPr>
+              <a:t>    public void </a:t>
+            </a:r>
+            <a:r>
+              <a:rPr lang="en-US" sz="1400" dirty="0" err="1">
+                <a:latin typeface="Consolas" panose="020B0609020204030204" pitchFamily="49" charset="0"/>
+                <a:cs typeface="Consolas" panose="020B0609020204030204" pitchFamily="49" charset="0"/>
+              </a:rPr>
+              <a:t>PrintLine</a:t>
+            </a:r>
+            <a:r>
+              <a:rPr lang="en-US" sz="1400" dirty="0">
+                <a:latin typeface="Consolas" panose="020B0609020204030204" pitchFamily="49" charset="0"/>
+                <a:cs typeface="Consolas" panose="020B0609020204030204" pitchFamily="49" charset="0"/>
+              </a:rPr>
+              <a:t>(string l) {</a:t>
+            </a:r>
+            <a:br>
+              <a:rPr lang="en-US" sz="1400" dirty="0">
+                <a:latin typeface="Consolas" panose="020B0609020204030204" pitchFamily="49" charset="0"/>
+                <a:cs typeface="Consolas" panose="020B0609020204030204" pitchFamily="49" charset="0"/>
+              </a:rPr>
+            </a:br>
+            <a:r>
+              <a:rPr lang="en-US" sz="1400" dirty="0">
+                <a:latin typeface="Consolas" panose="020B0609020204030204" pitchFamily="49" charset="0"/>
+                <a:cs typeface="Consolas" panose="020B0609020204030204" pitchFamily="49" charset="0"/>
+              </a:rPr>
+              <a:t>        </a:t>
+            </a:r>
+            <a:r>
+              <a:rPr lang="en-US" sz="1400" i="1" dirty="0">
+                <a:latin typeface="Consolas" panose="020B0609020204030204" pitchFamily="49" charset="0"/>
+                <a:cs typeface="Consolas" panose="020B0609020204030204" pitchFamily="49" charset="0"/>
+              </a:rPr>
+              <a:t>// .. print l on paper</a:t>
+            </a:r>
+            <a:br>
+              <a:rPr lang="en-US" sz="1400" i="1" dirty="0">
+                <a:latin typeface="Consolas" panose="020B0609020204030204" pitchFamily="49" charset="0"/>
+                <a:cs typeface="Consolas" panose="020B0609020204030204" pitchFamily="49" charset="0"/>
+              </a:rPr>
+            </a:br>
+            <a:r>
+              <a:rPr lang="en-US" sz="1400" i="1" dirty="0">
+                <a:latin typeface="Consolas" panose="020B0609020204030204" pitchFamily="49" charset="0"/>
+                <a:cs typeface="Consolas" panose="020B0609020204030204" pitchFamily="49" charset="0"/>
+              </a:rPr>
+              <a:t>    </a:t>
+            </a:r>
+            <a:r>
+              <a:rPr lang="en-US" sz="1400" dirty="0">
+                <a:latin typeface="Consolas" panose="020B0609020204030204" pitchFamily="49" charset="0"/>
+                <a:cs typeface="Consolas" panose="020B0609020204030204" pitchFamily="49" charset="0"/>
+              </a:rPr>
+              <a:t>}</a:t>
+            </a:r>
+            <a:br>
+              <a:rPr lang="en-US" sz="1400" dirty="0">
+                <a:latin typeface="Consolas" panose="020B0609020204030204" pitchFamily="49" charset="0"/>
+                <a:cs typeface="Consolas" panose="020B0609020204030204" pitchFamily="49" charset="0"/>
+              </a:rPr>
+            </a:br>
+            <a:r>
+              <a:rPr lang="en-US" sz="1400" dirty="0">
+                <a:latin typeface="Consolas" panose="020B0609020204030204" pitchFamily="49" charset="0"/>
+                <a:cs typeface="Consolas" panose="020B0609020204030204" pitchFamily="49" charset="0"/>
               </a:rPr>
               <a:t>}</a:t>
             </a:r>
           </a:p>
         </p:txBody>
       </p:sp>
-      <p:cxnSp>
-        <p:nvCxnSpPr>
-          <p:cNvPr id="12" name="Straight Arrow Connector 11"/>
-          <p:cNvCxnSpPr>
-            <a:stCxn id="11" idx="0"/>
-          </p:cNvCxnSpPr>
-          <p:nvPr/>
-        </p:nvCxnSpPr>
-        <p:spPr>
-          <a:xfrm flipH="1" flipV="1">
-            <a:off x="5786276" y="3645024"/>
-            <a:ext cx="914546" cy="1497996"/>
-          </a:xfrm>
-          <a:prstGeom prst="straightConnector1">
-            <a:avLst/>
-          </a:prstGeom>
-          <a:ln>
-            <a:tailEnd type="arrow"/>
-          </a:ln>
-        </p:spPr>
-        <p:style>
-          <a:lnRef idx="1">
-            <a:schemeClr val="accent1"/>
-          </a:lnRef>
-          <a:fillRef idx="0">
-            <a:schemeClr val="accent1"/>
-          </a:fillRef>
-          <a:effectRef idx="0">
-            <a:schemeClr val="accent1"/>
-          </a:effectRef>
-          <a:fontRef idx="minor">
-            <a:schemeClr val="tx1"/>
-          </a:fontRef>
-        </p:style>
-      </p:cxnSp>
       <p:sp>
         <p:nvSpPr>
           <p:cNvPr id="16" name="TextBox 15"/>
@@ -10429,13 +10203,15 @@
       <p:cxnSp>
         <p:nvCxnSpPr>
           <p:cNvPr id="14" name="Straight Arrow Connector 13"/>
-          <p:cNvCxnSpPr/>
+          <p:cNvCxnSpPr>
+            <a:cxnSpLocks/>
+          </p:cNvCxnSpPr>
           <p:nvPr/>
         </p:nvCxnSpPr>
         <p:spPr>
           <a:xfrm flipV="1">
-            <a:off x="2216793" y="3645024"/>
-            <a:ext cx="1139182" cy="897832"/>
+            <a:off x="2339752" y="3645024"/>
+            <a:ext cx="1016223" cy="966207"/>
           </a:xfrm>
           <a:prstGeom prst="straightConnector1">
             <a:avLst/>
@@ -10809,16 +10585,58 @@
           </a:extLst>
         </p:spPr>
       </p:pic>
+      <p:cxnSp>
+        <p:nvCxnSpPr>
+          <p:cNvPr id="21" name="Straight Arrow Connector 20"/>
+          <p:cNvCxnSpPr>
+            <a:cxnSpLocks/>
+            <a:endCxn id="2050" idx="2"/>
+          </p:cNvCxnSpPr>
+          <p:nvPr/>
+        </p:nvCxnSpPr>
+        <p:spPr>
+          <a:xfrm flipH="1" flipV="1">
+            <a:off x="5422699" y="3789363"/>
+            <a:ext cx="1232437" cy="1353657"/>
+          </a:xfrm>
+          <a:prstGeom prst="straightConnector1">
+            <a:avLst/>
+          </a:prstGeom>
+          <a:ln>
+            <a:tailEnd type="arrow"/>
+          </a:ln>
+        </p:spPr>
+        <p:style>
+          <a:lnRef idx="1">
+            <a:schemeClr val="accent1"/>
+          </a:lnRef>
+          <a:fillRef idx="0">
+            <a:schemeClr val="accent1"/>
+          </a:fillRef>
+          <a:effectRef idx="0">
+            <a:schemeClr val="accent1"/>
+          </a:effectRef>
+          <a:fontRef idx="minor">
+            <a:schemeClr val="tx1"/>
+          </a:fontRef>
+        </p:style>
+      </p:cxnSp>
       <p:sp>
         <p:nvSpPr>
-          <p:cNvPr id="20" name="TextBox 19"/>
+          <p:cNvPr id="3" name="TextBox 2">
+            <a:extLst>
+              <a:ext uri="{FF2B5EF4-FFF2-40B4-BE49-F238E27FC236}">
+                <a16:creationId xmlns:a16="http://schemas.microsoft.com/office/drawing/2014/main" id="{39CAA70A-12A4-0564-3D41-2D0E88E73D32}"/>
+              </a:ext>
+            </a:extLst>
+          </p:cNvPr>
           <p:cNvSpPr txBox="1"/>
           <p:nvPr/>
         </p:nvSpPr>
         <p:spPr>
           <a:xfrm>
-            <a:off x="479779" y="4542855"/>
-            <a:ext cx="3565400" cy="2092881"/>
+            <a:off x="4674916" y="5170992"/>
+            <a:ext cx="3960440" cy="1169551"/>
           </a:xfrm>
           <a:prstGeom prst="rect">
             <a:avLst/>
@@ -10846,213 +10664,103 @@
           <a:lstStyle/>
           <a:p>
             <a:r>
-              <a:rPr lang="da-DK" sz="1300" dirty="0" err="1">
-                <a:latin typeface="Consolas" pitchFamily="49" charset="0"/>
-                <a:cs typeface="Consolas" pitchFamily="49" charset="0"/>
-              </a:rPr>
-              <a:t>TextEditor</a:t>
-            </a:r>
-            <a:r>
-              <a:rPr lang="da-DK" sz="1300" dirty="0">
-                <a:latin typeface="Consolas" pitchFamily="49" charset="0"/>
-                <a:cs typeface="Consolas" pitchFamily="49" charset="0"/>
-              </a:rPr>
-              <a:t>::</a:t>
-            </a:r>
-            <a:r>
-              <a:rPr lang="da-DK" sz="1300" dirty="0" err="1">
-                <a:latin typeface="Consolas" pitchFamily="49" charset="0"/>
-                <a:cs typeface="Consolas" pitchFamily="49" charset="0"/>
-              </a:rPr>
-              <a:t>TextEditor</a:t>
-            </a:r>
-            <a:r>
-              <a:rPr lang="da-DK" sz="1300" dirty="0">
-                <a:latin typeface="Consolas" pitchFamily="49" charset="0"/>
-                <a:cs typeface="Consolas" pitchFamily="49" charset="0"/>
-              </a:rPr>
-              <a:t>()</a:t>
-            </a:r>
-          </a:p>
-          <a:p>
-            <a:r>
-              <a:rPr lang="da-DK" sz="1300" dirty="0">
-                <a:latin typeface="Consolas" pitchFamily="49" charset="0"/>
-                <a:cs typeface="Consolas" pitchFamily="49" charset="0"/>
-              </a:rPr>
-              <a:t>{</a:t>
-            </a:r>
-          </a:p>
-          <a:p>
-            <a:r>
-              <a:rPr lang="da-DK" sz="1300" dirty="0">
-                <a:latin typeface="Consolas" pitchFamily="49" charset="0"/>
-                <a:cs typeface="Consolas" pitchFamily="49" charset="0"/>
-              </a:rPr>
-              <a:t>  printer = new </a:t>
-            </a:r>
-            <a:r>
-              <a:rPr lang="da-DK" sz="1300" dirty="0" err="1">
-                <a:latin typeface="Consolas" pitchFamily="49" charset="0"/>
-                <a:cs typeface="Consolas" pitchFamily="49" charset="0"/>
-              </a:rPr>
-              <a:t>YeOlePrinter</a:t>
-            </a:r>
-            <a:r>
-              <a:rPr lang="da-DK" sz="1300" dirty="0">
-                <a:latin typeface="Consolas" pitchFamily="49" charset="0"/>
-                <a:cs typeface="Consolas" pitchFamily="49" charset="0"/>
-              </a:rPr>
-              <a:t>()</a:t>
-            </a:r>
-          </a:p>
-          <a:p>
-            <a:r>
-              <a:rPr lang="da-DK" sz="1300" dirty="0">
-                <a:latin typeface="Consolas" pitchFamily="49" charset="0"/>
-                <a:cs typeface="Consolas" pitchFamily="49" charset="0"/>
+              <a:rPr lang="en-US" sz="1400" dirty="0">
+                <a:latin typeface="Consolas" panose="020B0609020204030204" pitchFamily="49" charset="0"/>
+                <a:cs typeface="Consolas" panose="020B0609020204030204" pitchFamily="49" charset="0"/>
+              </a:rPr>
+              <a:t>public class </a:t>
+            </a:r>
+            <a:r>
+              <a:rPr lang="en-US" sz="1400" dirty="0" err="1">
+                <a:latin typeface="Consolas" panose="020B0609020204030204" pitchFamily="49" charset="0"/>
+                <a:cs typeface="Consolas" panose="020B0609020204030204" pitchFamily="49" charset="0"/>
+              </a:rPr>
+              <a:t>YeOldPrinter</a:t>
+            </a:r>
+            <a:r>
+              <a:rPr lang="en-US" sz="1400" dirty="0">
+                <a:latin typeface="Consolas" panose="020B0609020204030204" pitchFamily="49" charset="0"/>
+                <a:cs typeface="Consolas" panose="020B0609020204030204" pitchFamily="49" charset="0"/>
+              </a:rPr>
+              <a:t> {</a:t>
+            </a:r>
+            <a:br>
+              <a:rPr lang="en-US" sz="1400" dirty="0">
+                <a:latin typeface="Consolas" panose="020B0609020204030204" pitchFamily="49" charset="0"/>
+                <a:cs typeface="Consolas" panose="020B0609020204030204" pitchFamily="49" charset="0"/>
+              </a:rPr>
+            </a:br>
+            <a:r>
+              <a:rPr lang="en-US" sz="1400" dirty="0">
+                <a:latin typeface="Consolas" panose="020B0609020204030204" pitchFamily="49" charset="0"/>
+                <a:cs typeface="Consolas" panose="020B0609020204030204" pitchFamily="49" charset="0"/>
+              </a:rPr>
+              <a:t>    public void </a:t>
+            </a:r>
+            <a:r>
+              <a:rPr lang="en-US" sz="1400" dirty="0" err="1">
+                <a:latin typeface="Consolas" panose="020B0609020204030204" pitchFamily="49" charset="0"/>
+                <a:cs typeface="Consolas" panose="020B0609020204030204" pitchFamily="49" charset="0"/>
+              </a:rPr>
+              <a:t>PrintChar</a:t>
+            </a:r>
+            <a:r>
+              <a:rPr lang="en-US" sz="1400" dirty="0">
+                <a:latin typeface="Consolas" panose="020B0609020204030204" pitchFamily="49" charset="0"/>
+                <a:cs typeface="Consolas" panose="020B0609020204030204" pitchFamily="49" charset="0"/>
+              </a:rPr>
+              <a:t>(char c) {</a:t>
+            </a:r>
+            <a:br>
+              <a:rPr lang="en-US" sz="1400" dirty="0">
+                <a:latin typeface="Consolas" panose="020B0609020204030204" pitchFamily="49" charset="0"/>
+                <a:cs typeface="Consolas" panose="020B0609020204030204" pitchFamily="49" charset="0"/>
+              </a:rPr>
+            </a:br>
+            <a:r>
+              <a:rPr lang="en-US" sz="1400" dirty="0">
+                <a:latin typeface="Consolas" panose="020B0609020204030204" pitchFamily="49" charset="0"/>
+                <a:cs typeface="Consolas" panose="020B0609020204030204" pitchFamily="49" charset="0"/>
+              </a:rPr>
+              <a:t>        </a:t>
+            </a:r>
+            <a:r>
+              <a:rPr lang="en-US" sz="1400" i="1" dirty="0">
+                <a:latin typeface="Consolas" panose="020B0609020204030204" pitchFamily="49" charset="0"/>
+                <a:cs typeface="Consolas" panose="020B0609020204030204" pitchFamily="49" charset="0"/>
+              </a:rPr>
+              <a:t>// .. print c on paper</a:t>
+            </a:r>
+            <a:br>
+              <a:rPr lang="en-US" sz="1400" i="1" dirty="0">
+                <a:latin typeface="Consolas" panose="020B0609020204030204" pitchFamily="49" charset="0"/>
+                <a:cs typeface="Consolas" panose="020B0609020204030204" pitchFamily="49" charset="0"/>
+              </a:rPr>
+            </a:br>
+            <a:r>
+              <a:rPr lang="en-US" sz="1400" i="1" dirty="0">
+                <a:latin typeface="Consolas" panose="020B0609020204030204" pitchFamily="49" charset="0"/>
+                <a:cs typeface="Consolas" panose="020B0609020204030204" pitchFamily="49" charset="0"/>
+              </a:rPr>
+              <a:t>    </a:t>
+            </a:r>
+            <a:r>
+              <a:rPr lang="en-US" sz="1400" dirty="0">
+                <a:latin typeface="Consolas" panose="020B0609020204030204" pitchFamily="49" charset="0"/>
+                <a:cs typeface="Consolas" panose="020B0609020204030204" pitchFamily="49" charset="0"/>
               </a:rPr>
               <a:t>}</a:t>
             </a:r>
-          </a:p>
-          <a:p>
-            <a:endParaRPr lang="da-DK" sz="1300" dirty="0">
-              <a:latin typeface="Consolas" pitchFamily="49" charset="0"/>
-              <a:cs typeface="Consolas" pitchFamily="49" charset="0"/>
-            </a:endParaRPr>
-          </a:p>
-          <a:p>
-            <a:r>
-              <a:rPr lang="da-DK" sz="1300" dirty="0" err="1">
-                <a:latin typeface="Consolas" pitchFamily="49" charset="0"/>
-                <a:cs typeface="Consolas" pitchFamily="49" charset="0"/>
-              </a:rPr>
-              <a:t>void</a:t>
-            </a:r>
-            <a:r>
-              <a:rPr lang="da-DK" sz="1300" dirty="0">
-                <a:latin typeface="Consolas" pitchFamily="49" charset="0"/>
-                <a:cs typeface="Consolas" pitchFamily="49" charset="0"/>
-              </a:rPr>
-              <a:t> </a:t>
-            </a:r>
-            <a:r>
-              <a:rPr lang="da-DK" sz="1300" dirty="0" err="1">
-                <a:latin typeface="Consolas" pitchFamily="49" charset="0"/>
-                <a:cs typeface="Consolas" pitchFamily="49" charset="0"/>
-              </a:rPr>
-              <a:t>TextEditor</a:t>
-            </a:r>
-            <a:r>
-              <a:rPr lang="da-DK" sz="1300" dirty="0">
-                <a:latin typeface="Consolas" pitchFamily="49" charset="0"/>
-                <a:cs typeface="Consolas" pitchFamily="49" charset="0"/>
-              </a:rPr>
-              <a:t>::</a:t>
-            </a:r>
-            <a:r>
-              <a:rPr lang="da-DK" sz="1300" dirty="0" err="1">
-                <a:latin typeface="Consolas" pitchFamily="49" charset="0"/>
-                <a:cs typeface="Consolas" pitchFamily="49" charset="0"/>
-              </a:rPr>
-              <a:t>OnButtonPrint</a:t>
-            </a:r>
-            <a:r>
-              <a:rPr lang="da-DK" sz="1300" dirty="0">
-                <a:latin typeface="Consolas" pitchFamily="49" charset="0"/>
-                <a:cs typeface="Consolas" pitchFamily="49" charset="0"/>
-              </a:rPr>
-              <a:t>()</a:t>
-            </a:r>
-          </a:p>
-          <a:p>
-            <a:r>
-              <a:rPr lang="da-DK" sz="1300" dirty="0">
-                <a:latin typeface="Consolas" pitchFamily="49" charset="0"/>
-                <a:cs typeface="Consolas" pitchFamily="49" charset="0"/>
-              </a:rPr>
-              <a:t>{</a:t>
-            </a:r>
-          </a:p>
-          <a:p>
-            <a:r>
-              <a:rPr lang="da-DK" sz="1300" dirty="0">
-                <a:latin typeface="Consolas" pitchFamily="49" charset="0"/>
-                <a:cs typeface="Consolas" pitchFamily="49" charset="0"/>
-              </a:rPr>
-              <a:t>  for </a:t>
-            </a:r>
-            <a:r>
-              <a:rPr lang="da-DK" sz="1300" dirty="0" err="1">
-                <a:latin typeface="Consolas" pitchFamily="49" charset="0"/>
-                <a:cs typeface="Consolas" pitchFamily="49" charset="0"/>
-              </a:rPr>
-              <a:t>each</a:t>
-            </a:r>
-            <a:r>
-              <a:rPr lang="da-DK" sz="1300" dirty="0">
-                <a:latin typeface="Consolas" pitchFamily="49" charset="0"/>
-                <a:cs typeface="Consolas" pitchFamily="49" charset="0"/>
-              </a:rPr>
-              <a:t> </a:t>
-            </a:r>
-            <a:r>
-              <a:rPr lang="da-DK" sz="1300" dirty="0" err="1">
-                <a:latin typeface="Consolas" pitchFamily="49" charset="0"/>
-                <a:cs typeface="Consolas" pitchFamily="49" charset="0"/>
-              </a:rPr>
-              <a:t>char</a:t>
-            </a:r>
-            <a:r>
-              <a:rPr lang="da-DK" sz="1300" dirty="0">
-                <a:latin typeface="Consolas" pitchFamily="49" charset="0"/>
-                <a:cs typeface="Consolas" pitchFamily="49" charset="0"/>
-              </a:rPr>
-              <a:t> c in </a:t>
-            </a:r>
-            <a:r>
-              <a:rPr lang="da-DK" sz="1300" dirty="0" err="1">
-                <a:latin typeface="Consolas" pitchFamily="49" charset="0"/>
-                <a:cs typeface="Consolas" pitchFamily="49" charset="0"/>
-              </a:rPr>
-              <a:t>currentText</a:t>
-            </a:r>
-            <a:r>
-              <a:rPr lang="da-DK" sz="1300" dirty="0">
-                <a:latin typeface="Consolas" pitchFamily="49" charset="0"/>
-                <a:cs typeface="Consolas" pitchFamily="49" charset="0"/>
-              </a:rPr>
-              <a:t>:</a:t>
-            </a:r>
-          </a:p>
-          <a:p>
-            <a:r>
-              <a:rPr lang="da-DK" sz="1300" dirty="0">
-                <a:latin typeface="Consolas" pitchFamily="49" charset="0"/>
-                <a:cs typeface="Consolas" pitchFamily="49" charset="0"/>
-              </a:rPr>
-              <a:t>    </a:t>
-            </a:r>
-            <a:r>
-              <a:rPr lang="da-DK" sz="1300" dirty="0" err="1">
-                <a:latin typeface="Consolas" pitchFamily="49" charset="0"/>
-                <a:cs typeface="Consolas" pitchFamily="49" charset="0"/>
-              </a:rPr>
-              <a:t>printer.printChar</a:t>
-            </a:r>
-            <a:r>
-              <a:rPr lang="da-DK" sz="1300" dirty="0">
-                <a:latin typeface="Consolas" pitchFamily="49" charset="0"/>
-                <a:cs typeface="Consolas" pitchFamily="49" charset="0"/>
-              </a:rPr>
-              <a:t>(c)</a:t>
-            </a:r>
-          </a:p>
-          <a:p>
-            <a:r>
-              <a:rPr lang="da-DK" sz="1300" dirty="0">
-                <a:latin typeface="Consolas" pitchFamily="49" charset="0"/>
-                <a:cs typeface="Consolas" pitchFamily="49" charset="0"/>
+            <a:br>
+              <a:rPr lang="en-US" sz="1400" dirty="0">
+                <a:latin typeface="Consolas" panose="020B0609020204030204" pitchFamily="49" charset="0"/>
+                <a:cs typeface="Consolas" panose="020B0609020204030204" pitchFamily="49" charset="0"/>
+              </a:rPr>
+            </a:br>
+            <a:r>
+              <a:rPr lang="en-US" sz="1400" dirty="0">
+                <a:latin typeface="Consolas" panose="020B0609020204030204" pitchFamily="49" charset="0"/>
+                <a:cs typeface="Consolas" panose="020B0609020204030204" pitchFamily="49" charset="0"/>
               </a:rPr>
               <a:t>}</a:t>
             </a:r>
@@ -11061,14 +10769,20 @@
       </p:sp>
       <p:sp>
         <p:nvSpPr>
-          <p:cNvPr id="15" name="TextBox 14"/>
+          <p:cNvPr id="8" name="TextBox 7">
+            <a:extLst>
+              <a:ext uri="{FF2B5EF4-FFF2-40B4-BE49-F238E27FC236}">
+                <a16:creationId xmlns:a16="http://schemas.microsoft.com/office/drawing/2014/main" id="{A44BB4F6-6CFE-65FB-9482-9C382401B1B7}"/>
+              </a:ext>
+            </a:extLst>
+          </p:cNvPr>
           <p:cNvSpPr txBox="1"/>
           <p:nvPr/>
         </p:nvSpPr>
         <p:spPr>
           <a:xfrm>
-            <a:off x="476692" y="4539887"/>
-            <a:ext cx="3560051" cy="2092881"/>
+            <a:off x="469236" y="4611231"/>
+            <a:ext cx="4022256" cy="2246769"/>
           </a:xfrm>
           <a:prstGeom prst="rect">
             <a:avLst/>
@@ -11096,220 +10810,196 @@
           <a:lstStyle/>
           <a:p>
             <a:r>
-              <a:rPr lang="da-DK" sz="1300" dirty="0" err="1">
-                <a:latin typeface="Consolas" pitchFamily="49" charset="0"/>
-                <a:cs typeface="Consolas" pitchFamily="49" charset="0"/>
+              <a:rPr lang="en-US" sz="1400" dirty="0">
+                <a:latin typeface="Consolas" panose="020B0609020204030204" pitchFamily="49" charset="0"/>
+                <a:cs typeface="Consolas" panose="020B0609020204030204" pitchFamily="49" charset="0"/>
+              </a:rPr>
+              <a:t>public class </a:t>
+            </a:r>
+            <a:r>
+              <a:rPr lang="en-US" sz="1400" dirty="0" err="1">
+                <a:latin typeface="Consolas" panose="020B0609020204030204" pitchFamily="49" charset="0"/>
+                <a:cs typeface="Consolas" panose="020B0609020204030204" pitchFamily="49" charset="0"/>
               </a:rPr>
               <a:t>TextEditor</a:t>
             </a:r>
             <a:r>
-              <a:rPr lang="da-DK" sz="1300" dirty="0">
-                <a:latin typeface="Consolas" pitchFamily="49" charset="0"/>
-                <a:cs typeface="Consolas" pitchFamily="49" charset="0"/>
-              </a:rPr>
-              <a:t>::</a:t>
-            </a:r>
-            <a:r>
-              <a:rPr lang="da-DK" sz="1300" dirty="0" err="1">
-                <a:latin typeface="Consolas" pitchFamily="49" charset="0"/>
-                <a:cs typeface="Consolas" pitchFamily="49" charset="0"/>
+              <a:rPr lang="en-US" sz="1400" dirty="0">
+                <a:latin typeface="Consolas" panose="020B0609020204030204" pitchFamily="49" charset="0"/>
+                <a:cs typeface="Consolas" panose="020B0609020204030204" pitchFamily="49" charset="0"/>
+              </a:rPr>
+              <a:t> {</a:t>
+            </a:r>
+            <a:br>
+              <a:rPr lang="en-US" sz="1400" dirty="0">
+                <a:latin typeface="Consolas" panose="020B0609020204030204" pitchFamily="49" charset="0"/>
+                <a:cs typeface="Consolas" panose="020B0609020204030204" pitchFamily="49" charset="0"/>
+              </a:rPr>
+            </a:br>
+            <a:r>
+              <a:rPr lang="en-US" sz="1400" dirty="0">
+                <a:latin typeface="Consolas" panose="020B0609020204030204" pitchFamily="49" charset="0"/>
+                <a:cs typeface="Consolas" panose="020B0609020204030204" pitchFamily="49" charset="0"/>
+              </a:rPr>
+              <a:t>    public </a:t>
+            </a:r>
+            <a:r>
+              <a:rPr lang="en-US" sz="1400" dirty="0" err="1">
+                <a:latin typeface="Consolas" panose="020B0609020204030204" pitchFamily="49" charset="0"/>
+                <a:cs typeface="Consolas" panose="020B0609020204030204" pitchFamily="49" charset="0"/>
               </a:rPr>
               <a:t>TextEditor</a:t>
             </a:r>
             <a:r>
-              <a:rPr lang="da-DK" sz="1300" dirty="0">
-                <a:latin typeface="Consolas" pitchFamily="49" charset="0"/>
-                <a:cs typeface="Consolas" pitchFamily="49" charset="0"/>
-              </a:rPr>
-              <a:t>()</a:t>
-            </a:r>
-          </a:p>
-          <a:p>
-            <a:r>
-              <a:rPr lang="da-DK" sz="1300" dirty="0">
-                <a:latin typeface="Consolas" pitchFamily="49" charset="0"/>
-                <a:cs typeface="Consolas" pitchFamily="49" charset="0"/>
-              </a:rPr>
-              <a:t>{</a:t>
-            </a:r>
-          </a:p>
-          <a:p>
-            <a:r>
-              <a:rPr lang="da-DK" sz="1300" dirty="0">
-                <a:latin typeface="Consolas" pitchFamily="49" charset="0"/>
-                <a:cs typeface="Consolas" pitchFamily="49" charset="0"/>
-              </a:rPr>
-              <a:t>  printer = new </a:t>
-            </a:r>
-            <a:r>
-              <a:rPr lang="da-DK" sz="1300" b="1" dirty="0" err="1">
-                <a:latin typeface="Consolas" pitchFamily="49" charset="0"/>
-                <a:cs typeface="Consolas" pitchFamily="49" charset="0"/>
+              <a:rPr lang="en-US" sz="1400" dirty="0">
+                <a:latin typeface="Consolas" panose="020B0609020204030204" pitchFamily="49" charset="0"/>
+                <a:cs typeface="Consolas" panose="020B0609020204030204" pitchFamily="49" charset="0"/>
+              </a:rPr>
+              <a:t>() {</a:t>
+            </a:r>
+            <a:br>
+              <a:rPr lang="en-US" sz="1400" dirty="0">
+                <a:latin typeface="Consolas" panose="020B0609020204030204" pitchFamily="49" charset="0"/>
+                <a:cs typeface="Consolas" panose="020B0609020204030204" pitchFamily="49" charset="0"/>
+              </a:rPr>
+            </a:br>
+            <a:r>
+              <a:rPr lang="en-US" sz="1400" dirty="0">
+                <a:latin typeface="Consolas" panose="020B0609020204030204" pitchFamily="49" charset="0"/>
+                <a:cs typeface="Consolas" panose="020B0609020204030204" pitchFamily="49" charset="0"/>
+              </a:rPr>
+              <a:t>        _printer = new </a:t>
+            </a:r>
+            <a:r>
+              <a:rPr lang="en-US" sz="1400" dirty="0" err="1">
+                <a:latin typeface="Consolas" panose="020B0609020204030204" pitchFamily="49" charset="0"/>
+                <a:cs typeface="Consolas" panose="020B0609020204030204" pitchFamily="49" charset="0"/>
               </a:rPr>
               <a:t>TheNewPrinter</a:t>
             </a:r>
             <a:r>
-              <a:rPr lang="da-DK" sz="1300" dirty="0">
-                <a:latin typeface="Consolas" pitchFamily="49" charset="0"/>
-                <a:cs typeface="Consolas" pitchFamily="49" charset="0"/>
-              </a:rPr>
-              <a:t>()</a:t>
-            </a:r>
-          </a:p>
-          <a:p>
-            <a:r>
-              <a:rPr lang="da-DK" sz="1300" dirty="0">
-                <a:latin typeface="Consolas" pitchFamily="49" charset="0"/>
-                <a:cs typeface="Consolas" pitchFamily="49" charset="0"/>
-              </a:rPr>
-              <a:t>}</a:t>
-            </a:r>
-          </a:p>
-          <a:p>
-            <a:endParaRPr lang="da-DK" sz="1300" dirty="0">
-              <a:latin typeface="Consolas" pitchFamily="49" charset="0"/>
-              <a:cs typeface="Consolas" pitchFamily="49" charset="0"/>
-            </a:endParaRPr>
-          </a:p>
-          <a:p>
-            <a:r>
-              <a:rPr lang="da-DK" sz="1300" dirty="0" err="1">
-                <a:latin typeface="Consolas" pitchFamily="49" charset="0"/>
-                <a:cs typeface="Consolas" pitchFamily="49" charset="0"/>
-              </a:rPr>
-              <a:t>void</a:t>
-            </a:r>
-            <a:r>
-              <a:rPr lang="da-DK" sz="1300" dirty="0">
-                <a:latin typeface="Consolas" pitchFamily="49" charset="0"/>
-                <a:cs typeface="Consolas" pitchFamily="49" charset="0"/>
-              </a:rPr>
-              <a:t> </a:t>
-            </a:r>
-            <a:r>
-              <a:rPr lang="da-DK" sz="1300" dirty="0" err="1">
-                <a:latin typeface="Consolas" pitchFamily="49" charset="0"/>
-                <a:cs typeface="Consolas" pitchFamily="49" charset="0"/>
-              </a:rPr>
-              <a:t>TextEditor</a:t>
-            </a:r>
-            <a:r>
-              <a:rPr lang="da-DK" sz="1300" dirty="0">
-                <a:latin typeface="Consolas" pitchFamily="49" charset="0"/>
-                <a:cs typeface="Consolas" pitchFamily="49" charset="0"/>
-              </a:rPr>
-              <a:t>::</a:t>
-            </a:r>
-            <a:r>
-              <a:rPr lang="da-DK" sz="1300" dirty="0" err="1">
-                <a:latin typeface="Consolas" pitchFamily="49" charset="0"/>
-                <a:cs typeface="Consolas" pitchFamily="49" charset="0"/>
-              </a:rPr>
-              <a:t>OnButtonPrint</a:t>
-            </a:r>
-            <a:r>
-              <a:rPr lang="da-DK" sz="1300" dirty="0">
-                <a:latin typeface="Consolas" pitchFamily="49" charset="0"/>
-                <a:cs typeface="Consolas" pitchFamily="49" charset="0"/>
-              </a:rPr>
-              <a:t>()</a:t>
-            </a:r>
-          </a:p>
-          <a:p>
-            <a:r>
-              <a:rPr lang="da-DK" sz="1300" dirty="0">
-                <a:latin typeface="Consolas" pitchFamily="49" charset="0"/>
-                <a:cs typeface="Consolas" pitchFamily="49" charset="0"/>
-              </a:rPr>
-              <a:t>{</a:t>
-            </a:r>
-          </a:p>
-          <a:p>
-            <a:r>
-              <a:rPr lang="da-DK" sz="1300" dirty="0">
-                <a:latin typeface="Consolas" pitchFamily="49" charset="0"/>
-                <a:cs typeface="Consolas" pitchFamily="49" charset="0"/>
-              </a:rPr>
-              <a:t>  for </a:t>
-            </a:r>
-            <a:r>
-              <a:rPr lang="da-DK" sz="1300" dirty="0" err="1">
-                <a:latin typeface="Consolas" pitchFamily="49" charset="0"/>
-                <a:cs typeface="Consolas" pitchFamily="49" charset="0"/>
-              </a:rPr>
-              <a:t>each</a:t>
-            </a:r>
-            <a:r>
-              <a:rPr lang="da-DK" sz="1300" dirty="0">
-                <a:latin typeface="Consolas" pitchFamily="49" charset="0"/>
-                <a:cs typeface="Consolas" pitchFamily="49" charset="0"/>
-              </a:rPr>
-              <a:t> </a:t>
-            </a:r>
-            <a:r>
-              <a:rPr lang="da-DK" sz="1300" b="1" dirty="0">
-                <a:latin typeface="Consolas" pitchFamily="49" charset="0"/>
-                <a:cs typeface="Consolas" pitchFamily="49" charset="0"/>
-              </a:rPr>
-              <a:t>line l</a:t>
-            </a:r>
-            <a:r>
-              <a:rPr lang="da-DK" sz="1300" dirty="0">
-                <a:latin typeface="Consolas" pitchFamily="49" charset="0"/>
-                <a:cs typeface="Consolas" pitchFamily="49" charset="0"/>
-              </a:rPr>
-              <a:t> in </a:t>
-            </a:r>
-            <a:r>
-              <a:rPr lang="da-DK" sz="1300" dirty="0" err="1">
-                <a:latin typeface="Consolas" pitchFamily="49" charset="0"/>
-                <a:cs typeface="Consolas" pitchFamily="49" charset="0"/>
-              </a:rPr>
-              <a:t>currentText</a:t>
-            </a:r>
-            <a:r>
-              <a:rPr lang="da-DK" sz="1300" dirty="0">
-                <a:latin typeface="Consolas" pitchFamily="49" charset="0"/>
-                <a:cs typeface="Consolas" pitchFamily="49" charset="0"/>
-              </a:rPr>
-              <a:t>:</a:t>
-            </a:r>
-          </a:p>
-          <a:p>
-            <a:r>
-              <a:rPr lang="da-DK" sz="1300" dirty="0">
-                <a:latin typeface="Consolas" pitchFamily="49" charset="0"/>
-                <a:cs typeface="Consolas" pitchFamily="49" charset="0"/>
-              </a:rPr>
-              <a:t>    </a:t>
-            </a:r>
-            <a:r>
-              <a:rPr lang="da-DK" sz="1300" dirty="0" err="1">
-                <a:latin typeface="Consolas" pitchFamily="49" charset="0"/>
-                <a:cs typeface="Consolas" pitchFamily="49" charset="0"/>
-              </a:rPr>
-              <a:t>printer.</a:t>
-            </a:r>
-            <a:r>
-              <a:rPr lang="da-DK" sz="1300" b="1" dirty="0" err="1">
-                <a:latin typeface="Consolas" pitchFamily="49" charset="0"/>
-                <a:cs typeface="Consolas" pitchFamily="49" charset="0"/>
-              </a:rPr>
-              <a:t>printLine</a:t>
-            </a:r>
-            <a:r>
-              <a:rPr lang="da-DK" sz="1300" b="1" dirty="0">
-                <a:latin typeface="Consolas" pitchFamily="49" charset="0"/>
-                <a:cs typeface="Consolas" pitchFamily="49" charset="0"/>
-              </a:rPr>
-              <a:t>(l)</a:t>
-            </a:r>
-          </a:p>
-          <a:p>
-            <a:r>
-              <a:rPr lang="da-DK" sz="1300" dirty="0">
-                <a:latin typeface="Consolas" pitchFamily="49" charset="0"/>
-                <a:cs typeface="Consolas" pitchFamily="49" charset="0"/>
+              <a:rPr lang="en-US" sz="1400" dirty="0">
+                <a:latin typeface="Consolas" panose="020B0609020204030204" pitchFamily="49" charset="0"/>
+                <a:cs typeface="Consolas" panose="020B0609020204030204" pitchFamily="49" charset="0"/>
+              </a:rPr>
+              <a:t>();</a:t>
+            </a:r>
+            <a:br>
+              <a:rPr lang="en-US" sz="1400" dirty="0">
+                <a:latin typeface="Consolas" panose="020B0609020204030204" pitchFamily="49" charset="0"/>
+                <a:cs typeface="Consolas" panose="020B0609020204030204" pitchFamily="49" charset="0"/>
+              </a:rPr>
+            </a:br>
+            <a:r>
+              <a:rPr lang="en-US" sz="1400" dirty="0">
+                <a:latin typeface="Consolas" panose="020B0609020204030204" pitchFamily="49" charset="0"/>
+                <a:cs typeface="Consolas" panose="020B0609020204030204" pitchFamily="49" charset="0"/>
+              </a:rPr>
+              <a:t>    }</a:t>
+            </a:r>
+            <a:br>
+              <a:rPr lang="en-US" sz="1400" dirty="0">
+                <a:latin typeface="Consolas" panose="020B0609020204030204" pitchFamily="49" charset="0"/>
+                <a:cs typeface="Consolas" panose="020B0609020204030204" pitchFamily="49" charset="0"/>
+              </a:rPr>
+            </a:br>
+            <a:r>
+              <a:rPr lang="en-US" sz="1400" dirty="0">
+                <a:latin typeface="Consolas" panose="020B0609020204030204" pitchFamily="49" charset="0"/>
+                <a:cs typeface="Consolas" panose="020B0609020204030204" pitchFamily="49" charset="0"/>
+              </a:rPr>
+              <a:t>    public void </a:t>
+            </a:r>
+            <a:r>
+              <a:rPr lang="en-US" sz="1400" dirty="0" err="1">
+                <a:latin typeface="Consolas" panose="020B0609020204030204" pitchFamily="49" charset="0"/>
+                <a:cs typeface="Consolas" panose="020B0609020204030204" pitchFamily="49" charset="0"/>
+              </a:rPr>
+              <a:t>OnPrintButton</a:t>
+            </a:r>
+            <a:r>
+              <a:rPr lang="en-US" sz="1400" dirty="0">
+                <a:latin typeface="Consolas" panose="020B0609020204030204" pitchFamily="49" charset="0"/>
+                <a:cs typeface="Consolas" panose="020B0609020204030204" pitchFamily="49" charset="0"/>
+              </a:rPr>
+              <a:t>() {</a:t>
+            </a:r>
+            <a:br>
+              <a:rPr lang="en-US" sz="1400" dirty="0">
+                <a:latin typeface="Consolas" panose="020B0609020204030204" pitchFamily="49" charset="0"/>
+                <a:cs typeface="Consolas" panose="020B0609020204030204" pitchFamily="49" charset="0"/>
+              </a:rPr>
+            </a:br>
+            <a:r>
+              <a:rPr lang="en-US" sz="1400" dirty="0">
+                <a:latin typeface="Consolas" panose="020B0609020204030204" pitchFamily="49" charset="0"/>
+                <a:cs typeface="Consolas" panose="020B0609020204030204" pitchFamily="49" charset="0"/>
+              </a:rPr>
+              <a:t>        foreach (char c in text) {</a:t>
+            </a:r>
+            <a:br>
+              <a:rPr lang="en-US" sz="1400" dirty="0">
+                <a:latin typeface="Consolas" panose="020B0609020204030204" pitchFamily="49" charset="0"/>
+                <a:cs typeface="Consolas" panose="020B0609020204030204" pitchFamily="49" charset="0"/>
+              </a:rPr>
+            </a:br>
+            <a:r>
+              <a:rPr lang="en-US" sz="1400" dirty="0">
+                <a:latin typeface="Consolas" panose="020B0609020204030204" pitchFamily="49" charset="0"/>
+                <a:cs typeface="Consolas" panose="020B0609020204030204" pitchFamily="49" charset="0"/>
+              </a:rPr>
+              <a:t>            _</a:t>
+            </a:r>
+            <a:r>
+              <a:rPr lang="en-US" sz="1400" dirty="0" err="1">
+                <a:latin typeface="Consolas" panose="020B0609020204030204" pitchFamily="49" charset="0"/>
+                <a:cs typeface="Consolas" panose="020B0609020204030204" pitchFamily="49" charset="0"/>
+              </a:rPr>
+              <a:t>printer.PrintChar</a:t>
+            </a:r>
+            <a:r>
+              <a:rPr lang="en-US" sz="1400" dirty="0">
+                <a:latin typeface="Consolas" panose="020B0609020204030204" pitchFamily="49" charset="0"/>
+                <a:cs typeface="Consolas" panose="020B0609020204030204" pitchFamily="49" charset="0"/>
+              </a:rPr>
+              <a:t>(c);</a:t>
+            </a:r>
+            <a:br>
+              <a:rPr lang="en-US" sz="1400" dirty="0">
+                <a:latin typeface="Consolas" panose="020B0609020204030204" pitchFamily="49" charset="0"/>
+                <a:cs typeface="Consolas" panose="020B0609020204030204" pitchFamily="49" charset="0"/>
+              </a:rPr>
+            </a:br>
+            <a:r>
+              <a:rPr lang="en-US" sz="1400" dirty="0">
+                <a:latin typeface="Consolas" panose="020B0609020204030204" pitchFamily="49" charset="0"/>
+                <a:cs typeface="Consolas" panose="020B0609020204030204" pitchFamily="49" charset="0"/>
+              </a:rPr>
+              <a:t>        }</a:t>
+            </a:r>
+            <a:br>
+              <a:rPr lang="en-US" sz="1400" dirty="0">
+                <a:latin typeface="Consolas" panose="020B0609020204030204" pitchFamily="49" charset="0"/>
+                <a:cs typeface="Consolas" panose="020B0609020204030204" pitchFamily="49" charset="0"/>
+              </a:rPr>
+            </a:br>
+            <a:r>
+              <a:rPr lang="en-US" sz="1400" dirty="0">
+                <a:latin typeface="Consolas" panose="020B0609020204030204" pitchFamily="49" charset="0"/>
+                <a:cs typeface="Consolas" panose="020B0609020204030204" pitchFamily="49" charset="0"/>
+              </a:rPr>
+              <a:t>    }</a:t>
+            </a:r>
+            <a:br>
+              <a:rPr lang="en-US" sz="1400" dirty="0">
+                <a:latin typeface="Consolas" panose="020B0609020204030204" pitchFamily="49" charset="0"/>
+                <a:cs typeface="Consolas" panose="020B0609020204030204" pitchFamily="49" charset="0"/>
+              </a:rPr>
+            </a:br>
+            <a:r>
+              <a:rPr lang="en-US" sz="1400" dirty="0">
+                <a:latin typeface="Consolas" panose="020B0609020204030204" pitchFamily="49" charset="0"/>
+                <a:cs typeface="Consolas" panose="020B0609020204030204" pitchFamily="49" charset="0"/>
               </a:rPr>
               <a:t>}</a:t>
             </a:r>
@@ -11318,14 +11008,20 @@
       </p:sp>
       <p:sp>
         <p:nvSpPr>
-          <p:cNvPr id="17" name="TextBox 16"/>
+          <p:cNvPr id="7" name="TextBox 6">
+            <a:extLst>
+              <a:ext uri="{FF2B5EF4-FFF2-40B4-BE49-F238E27FC236}">
+                <a16:creationId xmlns:a16="http://schemas.microsoft.com/office/drawing/2014/main" id="{227B4A0D-5073-4171-8AD2-CCF241DB228D}"/>
+              </a:ext>
+            </a:extLst>
+          </p:cNvPr>
           <p:cNvSpPr txBox="1"/>
           <p:nvPr/>
         </p:nvSpPr>
         <p:spPr>
           <a:xfrm>
-            <a:off x="4644008" y="5143020"/>
-            <a:ext cx="4022255" cy="892552"/>
+            <a:off x="469236" y="4611231"/>
+            <a:ext cx="4022256" cy="2246769"/>
           </a:xfrm>
           <a:prstGeom prst="rect">
             <a:avLst/>
@@ -11347,171 +11043,208 @@
           </a:effectLst>
         </p:spPr>
         <p:txBody>
-          <a:bodyPr wrap="none" rtlCol="0">
+          <a:bodyPr wrap="square" rtlCol="0">
             <a:spAutoFit/>
           </a:bodyPr>
           <a:lstStyle/>
           <a:p>
             <a:r>
-              <a:rPr lang="da-DK" sz="1300" dirty="0" err="1">
-                <a:latin typeface="Consolas" pitchFamily="49" charset="0"/>
-                <a:cs typeface="Consolas" pitchFamily="49" charset="0"/>
-              </a:rPr>
-              <a:t>void</a:t>
-            </a:r>
-            <a:r>
-              <a:rPr lang="da-DK" sz="1300" dirty="0">
-                <a:latin typeface="Consolas" pitchFamily="49" charset="0"/>
-                <a:cs typeface="Consolas" pitchFamily="49" charset="0"/>
-              </a:rPr>
-              <a:t> </a:t>
-            </a:r>
-            <a:r>
-              <a:rPr lang="da-DK" sz="1300" dirty="0" err="1">
-                <a:latin typeface="Consolas" pitchFamily="49" charset="0"/>
-                <a:cs typeface="Consolas" pitchFamily="49" charset="0"/>
-              </a:rPr>
-              <a:t>YeOlePrinter</a:t>
-            </a:r>
-            <a:r>
-              <a:rPr lang="da-DK" sz="1300" dirty="0">
-                <a:latin typeface="Consolas" pitchFamily="49" charset="0"/>
-                <a:cs typeface="Consolas" pitchFamily="49" charset="0"/>
-              </a:rPr>
-              <a:t>::</a:t>
-            </a:r>
-            <a:r>
-              <a:rPr lang="da-DK" sz="1300" dirty="0" err="1">
-                <a:latin typeface="Consolas" pitchFamily="49" charset="0"/>
-                <a:cs typeface="Consolas" pitchFamily="49" charset="0"/>
-              </a:rPr>
-              <a:t>printChar</a:t>
-            </a:r>
-            <a:r>
-              <a:rPr lang="da-DK" sz="1300" dirty="0">
-                <a:latin typeface="Consolas" pitchFamily="49" charset="0"/>
-                <a:cs typeface="Consolas" pitchFamily="49" charset="0"/>
-              </a:rPr>
-              <a:t>(</a:t>
-            </a:r>
-            <a:r>
-              <a:rPr lang="da-DK" sz="1300" dirty="0" err="1">
-                <a:latin typeface="Consolas" pitchFamily="49" charset="0"/>
-                <a:cs typeface="Consolas" pitchFamily="49" charset="0"/>
-              </a:rPr>
-              <a:t>char</a:t>
-            </a:r>
-            <a:r>
-              <a:rPr lang="da-DK" sz="1300" dirty="0">
-                <a:latin typeface="Consolas" pitchFamily="49" charset="0"/>
-                <a:cs typeface="Consolas" pitchFamily="49" charset="0"/>
-              </a:rPr>
-              <a:t> c)</a:t>
-            </a:r>
-          </a:p>
-          <a:p>
-            <a:r>
-              <a:rPr lang="da-DK" sz="1300" dirty="0">
-                <a:latin typeface="Consolas" pitchFamily="49" charset="0"/>
-                <a:cs typeface="Consolas" pitchFamily="49" charset="0"/>
-              </a:rPr>
-              <a:t>{</a:t>
-            </a:r>
-          </a:p>
-          <a:p>
-            <a:r>
-              <a:rPr lang="da-DK" sz="1300" dirty="0">
-                <a:latin typeface="Consolas" pitchFamily="49" charset="0"/>
-                <a:cs typeface="Consolas" pitchFamily="49" charset="0"/>
-              </a:rPr>
-              <a:t>  // </a:t>
-            </a:r>
-            <a:r>
-              <a:rPr lang="da-DK" sz="1300" dirty="0" err="1">
-                <a:latin typeface="Consolas" pitchFamily="49" charset="0"/>
-                <a:cs typeface="Consolas" pitchFamily="49" charset="0"/>
-              </a:rPr>
-              <a:t>Whatever</a:t>
-            </a:r>
-            <a:r>
-              <a:rPr lang="da-DK" sz="1300" dirty="0">
-                <a:latin typeface="Consolas" pitchFamily="49" charset="0"/>
-                <a:cs typeface="Consolas" pitchFamily="49" charset="0"/>
-              </a:rPr>
-              <a:t> it </a:t>
-            </a:r>
-            <a:r>
-              <a:rPr lang="da-DK" sz="1300" dirty="0" err="1">
-                <a:latin typeface="Consolas" pitchFamily="49" charset="0"/>
-                <a:cs typeface="Consolas" pitchFamily="49" charset="0"/>
-              </a:rPr>
-              <a:t>takes</a:t>
-            </a:r>
-            <a:r>
-              <a:rPr lang="da-DK" sz="1300" dirty="0">
-                <a:latin typeface="Consolas" pitchFamily="49" charset="0"/>
-                <a:cs typeface="Consolas" pitchFamily="49" charset="0"/>
-              </a:rPr>
-              <a:t> to put ‘c’ on </a:t>
-            </a:r>
-            <a:r>
-              <a:rPr lang="da-DK" sz="1300" dirty="0" err="1">
-                <a:latin typeface="Consolas" pitchFamily="49" charset="0"/>
-                <a:cs typeface="Consolas" pitchFamily="49" charset="0"/>
-              </a:rPr>
-              <a:t>paper</a:t>
-            </a:r>
-            <a:endParaRPr lang="da-DK" sz="1300" dirty="0">
-              <a:latin typeface="Consolas" pitchFamily="49" charset="0"/>
-              <a:cs typeface="Consolas" pitchFamily="49" charset="0"/>
-            </a:endParaRPr>
-          </a:p>
-          <a:p>
-            <a:r>
-              <a:rPr lang="da-DK" sz="1300" dirty="0">
-                <a:latin typeface="Consolas" pitchFamily="49" charset="0"/>
-                <a:cs typeface="Consolas" pitchFamily="49" charset="0"/>
+              <a:rPr lang="en-US" sz="1400" dirty="0">
+                <a:latin typeface="Consolas" panose="020B0609020204030204" pitchFamily="49" charset="0"/>
+                <a:cs typeface="Consolas" panose="020B0609020204030204" pitchFamily="49" charset="0"/>
+              </a:rPr>
+              <a:t>public class </a:t>
+            </a:r>
+            <a:r>
+              <a:rPr lang="en-US" sz="1400" dirty="0" err="1">
+                <a:latin typeface="Consolas" panose="020B0609020204030204" pitchFamily="49" charset="0"/>
+                <a:cs typeface="Consolas" panose="020B0609020204030204" pitchFamily="49" charset="0"/>
+              </a:rPr>
+              <a:t>TextEditor</a:t>
+            </a:r>
+            <a:r>
+              <a:rPr lang="en-US" sz="1400" dirty="0">
+                <a:latin typeface="Consolas" panose="020B0609020204030204" pitchFamily="49" charset="0"/>
+                <a:cs typeface="Consolas" panose="020B0609020204030204" pitchFamily="49" charset="0"/>
+              </a:rPr>
+              <a:t> {</a:t>
+            </a:r>
+            <a:br>
+              <a:rPr lang="en-US" sz="1400" dirty="0">
+                <a:latin typeface="Consolas" panose="020B0609020204030204" pitchFamily="49" charset="0"/>
+                <a:cs typeface="Consolas" panose="020B0609020204030204" pitchFamily="49" charset="0"/>
+              </a:rPr>
+            </a:br>
+            <a:r>
+              <a:rPr lang="en-US" sz="1400" dirty="0">
+                <a:latin typeface="Consolas" panose="020B0609020204030204" pitchFamily="49" charset="0"/>
+                <a:cs typeface="Consolas" panose="020B0609020204030204" pitchFamily="49" charset="0"/>
+              </a:rPr>
+              <a:t>    public </a:t>
+            </a:r>
+            <a:r>
+              <a:rPr lang="en-US" sz="1400" dirty="0" err="1">
+                <a:latin typeface="Consolas" panose="020B0609020204030204" pitchFamily="49" charset="0"/>
+                <a:cs typeface="Consolas" panose="020B0609020204030204" pitchFamily="49" charset="0"/>
+              </a:rPr>
+              <a:t>TextEditor</a:t>
+            </a:r>
+            <a:r>
+              <a:rPr lang="en-US" sz="1400" dirty="0">
+                <a:latin typeface="Consolas" panose="020B0609020204030204" pitchFamily="49" charset="0"/>
+                <a:cs typeface="Consolas" panose="020B0609020204030204" pitchFamily="49" charset="0"/>
+              </a:rPr>
+              <a:t>() {</a:t>
+            </a:r>
+            <a:br>
+              <a:rPr lang="en-US" sz="1400" dirty="0">
+                <a:latin typeface="Consolas" panose="020B0609020204030204" pitchFamily="49" charset="0"/>
+                <a:cs typeface="Consolas" panose="020B0609020204030204" pitchFamily="49" charset="0"/>
+              </a:rPr>
+            </a:br>
+            <a:r>
+              <a:rPr lang="en-US" sz="1400" dirty="0">
+                <a:latin typeface="Consolas" panose="020B0609020204030204" pitchFamily="49" charset="0"/>
+                <a:cs typeface="Consolas" panose="020B0609020204030204" pitchFamily="49" charset="0"/>
+              </a:rPr>
+              <a:t>        _printer = new </a:t>
+            </a:r>
+            <a:r>
+              <a:rPr lang="en-US" sz="1400" dirty="0" err="1">
+                <a:latin typeface="Consolas" panose="020B0609020204030204" pitchFamily="49" charset="0"/>
+                <a:cs typeface="Consolas" panose="020B0609020204030204" pitchFamily="49" charset="0"/>
+              </a:rPr>
+              <a:t>YeOldPrinter</a:t>
+            </a:r>
+            <a:r>
+              <a:rPr lang="en-US" sz="1400" dirty="0">
+                <a:latin typeface="Consolas" panose="020B0609020204030204" pitchFamily="49" charset="0"/>
+                <a:cs typeface="Consolas" panose="020B0609020204030204" pitchFamily="49" charset="0"/>
+              </a:rPr>
+              <a:t>();</a:t>
+            </a:r>
+            <a:br>
+              <a:rPr lang="en-US" sz="1400" dirty="0">
+                <a:latin typeface="Consolas" panose="020B0609020204030204" pitchFamily="49" charset="0"/>
+                <a:cs typeface="Consolas" panose="020B0609020204030204" pitchFamily="49" charset="0"/>
+              </a:rPr>
+            </a:br>
+            <a:r>
+              <a:rPr lang="en-US" sz="1400" dirty="0">
+                <a:latin typeface="Consolas" panose="020B0609020204030204" pitchFamily="49" charset="0"/>
+                <a:cs typeface="Consolas" panose="020B0609020204030204" pitchFamily="49" charset="0"/>
+              </a:rPr>
+              <a:t>    }</a:t>
+            </a:r>
+            <a:br>
+              <a:rPr lang="en-US" sz="1400" dirty="0">
+                <a:latin typeface="Consolas" panose="020B0609020204030204" pitchFamily="49" charset="0"/>
+                <a:cs typeface="Consolas" panose="020B0609020204030204" pitchFamily="49" charset="0"/>
+              </a:rPr>
+            </a:br>
+            <a:r>
+              <a:rPr lang="en-US" sz="1400" dirty="0">
+                <a:latin typeface="Consolas" panose="020B0609020204030204" pitchFamily="49" charset="0"/>
+                <a:cs typeface="Consolas" panose="020B0609020204030204" pitchFamily="49" charset="0"/>
+              </a:rPr>
+              <a:t>    public void </a:t>
+            </a:r>
+            <a:r>
+              <a:rPr lang="en-US" sz="1400" dirty="0" err="1">
+                <a:latin typeface="Consolas" panose="020B0609020204030204" pitchFamily="49" charset="0"/>
+                <a:cs typeface="Consolas" panose="020B0609020204030204" pitchFamily="49" charset="0"/>
+              </a:rPr>
+              <a:t>OnPrintButton</a:t>
+            </a:r>
+            <a:r>
+              <a:rPr lang="en-US" sz="1400" dirty="0">
+                <a:latin typeface="Consolas" panose="020B0609020204030204" pitchFamily="49" charset="0"/>
+                <a:cs typeface="Consolas" panose="020B0609020204030204" pitchFamily="49" charset="0"/>
+              </a:rPr>
+              <a:t>() {</a:t>
+            </a:r>
+            <a:br>
+              <a:rPr lang="en-US" sz="1400" dirty="0">
+                <a:latin typeface="Consolas" panose="020B0609020204030204" pitchFamily="49" charset="0"/>
+                <a:cs typeface="Consolas" panose="020B0609020204030204" pitchFamily="49" charset="0"/>
+              </a:rPr>
+            </a:br>
+            <a:r>
+              <a:rPr lang="en-US" sz="1400" dirty="0">
+                <a:latin typeface="Consolas" panose="020B0609020204030204" pitchFamily="49" charset="0"/>
+                <a:cs typeface="Consolas" panose="020B0609020204030204" pitchFamily="49" charset="0"/>
+              </a:rPr>
+              <a:t>        foreach (char c in text) {</a:t>
+            </a:r>
+            <a:br>
+              <a:rPr lang="en-US" sz="1400" dirty="0">
+                <a:latin typeface="Consolas" panose="020B0609020204030204" pitchFamily="49" charset="0"/>
+                <a:cs typeface="Consolas" panose="020B0609020204030204" pitchFamily="49" charset="0"/>
+              </a:rPr>
+            </a:br>
+            <a:r>
+              <a:rPr lang="en-US" sz="1400" dirty="0">
+                <a:latin typeface="Consolas" panose="020B0609020204030204" pitchFamily="49" charset="0"/>
+                <a:cs typeface="Consolas" panose="020B0609020204030204" pitchFamily="49" charset="0"/>
+              </a:rPr>
+              <a:t>            _</a:t>
+            </a:r>
+            <a:r>
+              <a:rPr lang="en-US" sz="1400" dirty="0" err="1">
+                <a:latin typeface="Consolas" panose="020B0609020204030204" pitchFamily="49" charset="0"/>
+                <a:cs typeface="Consolas" panose="020B0609020204030204" pitchFamily="49" charset="0"/>
+              </a:rPr>
+              <a:t>printer.PrintChar</a:t>
+            </a:r>
+            <a:r>
+              <a:rPr lang="en-US" sz="1400" dirty="0">
+                <a:latin typeface="Consolas" panose="020B0609020204030204" pitchFamily="49" charset="0"/>
+                <a:cs typeface="Consolas" panose="020B0609020204030204" pitchFamily="49" charset="0"/>
+              </a:rPr>
+              <a:t>(c);</a:t>
+            </a:r>
+            <a:br>
+              <a:rPr lang="en-US" sz="1400" dirty="0">
+                <a:latin typeface="Consolas" panose="020B0609020204030204" pitchFamily="49" charset="0"/>
+                <a:cs typeface="Consolas" panose="020B0609020204030204" pitchFamily="49" charset="0"/>
+              </a:rPr>
+            </a:br>
+            <a:r>
+              <a:rPr lang="en-US" sz="1400" dirty="0">
+                <a:latin typeface="Consolas" panose="020B0609020204030204" pitchFamily="49" charset="0"/>
+                <a:cs typeface="Consolas" panose="020B0609020204030204" pitchFamily="49" charset="0"/>
+              </a:rPr>
+              <a:t>        }</a:t>
+            </a:r>
+            <a:br>
+              <a:rPr lang="en-US" sz="1400" dirty="0">
+                <a:latin typeface="Consolas" panose="020B0609020204030204" pitchFamily="49" charset="0"/>
+                <a:cs typeface="Consolas" panose="020B0609020204030204" pitchFamily="49" charset="0"/>
+              </a:rPr>
+            </a:br>
+            <a:r>
+              <a:rPr lang="en-US" sz="1400" dirty="0">
+                <a:latin typeface="Consolas" panose="020B0609020204030204" pitchFamily="49" charset="0"/>
+                <a:cs typeface="Consolas" panose="020B0609020204030204" pitchFamily="49" charset="0"/>
+              </a:rPr>
+              <a:t>    }</a:t>
+            </a:r>
+            <a:br>
+              <a:rPr lang="en-US" sz="1400" dirty="0">
+                <a:latin typeface="Consolas" panose="020B0609020204030204" pitchFamily="49" charset="0"/>
+                <a:cs typeface="Consolas" panose="020B0609020204030204" pitchFamily="49" charset="0"/>
+              </a:rPr>
+            </a:br>
+            <a:r>
+              <a:rPr lang="en-US" sz="1400" dirty="0">
+                <a:latin typeface="Consolas" panose="020B0609020204030204" pitchFamily="49" charset="0"/>
+                <a:cs typeface="Consolas" panose="020B0609020204030204" pitchFamily="49" charset="0"/>
               </a:rPr>
               <a:t>}</a:t>
             </a:r>
           </a:p>
         </p:txBody>
       </p:sp>
-      <p:cxnSp>
-        <p:nvCxnSpPr>
-          <p:cNvPr id="21" name="Straight Arrow Connector 20"/>
-          <p:cNvCxnSpPr>
-            <a:stCxn id="17" idx="0"/>
-          </p:cNvCxnSpPr>
-          <p:nvPr/>
-        </p:nvCxnSpPr>
-        <p:spPr>
-          <a:xfrm flipH="1" flipV="1">
-            <a:off x="5788026" y="3645024"/>
-            <a:ext cx="867110" cy="1497996"/>
-          </a:xfrm>
-          <a:prstGeom prst="straightConnector1">
-            <a:avLst/>
-          </a:prstGeom>
-          <a:ln>
-            <a:tailEnd type="arrow"/>
-          </a:ln>
-        </p:spPr>
-        <p:style>
-          <a:lnRef idx="1">
-            <a:schemeClr val="accent1"/>
-          </a:lnRef>
-          <a:fillRef idx="0">
-            <a:schemeClr val="accent1"/>
-          </a:fillRef>
-          <a:effectRef idx="0">
-            <a:schemeClr val="accent1"/>
-          </a:effectRef>
-          <a:fontRef idx="minor">
-            <a:schemeClr val="tx1"/>
-          </a:fontRef>
-        </p:style>
-      </p:cxnSp>
     </p:spTree>
     <p:extLst>
       <p:ext uri="{BB962C8B-B14F-4D97-AF65-F5344CB8AC3E}">
@@ -11670,94 +11403,24 @@
                                   </p:childTnLst>
                                 </p:cTn>
                               </p:par>
-                              <p:par>
-                                <p:cTn id="16" presetID="10" presetClass="exit" presetSubtype="0" fill="hold" grpId="1" nodeType="withEffect">
-                                  <p:stCondLst>
-                                    <p:cond delay="0"/>
-                                  </p:stCondLst>
-                                  <p:childTnLst>
-                                    <p:animEffect transition="out" filter="fade">
-                                      <p:cBhvr>
-                                        <p:cTn id="17" dur="500"/>
-                                        <p:tgtEl>
-                                          <p:spTgt spid="17"/>
-                                        </p:tgtEl>
-                                      </p:cBhvr>
-                                    </p:animEffect>
-                                    <p:set>
-                                      <p:cBhvr>
-                                        <p:cTn id="18" dur="1" fill="hold">
-                                          <p:stCondLst>
-                                            <p:cond delay="499"/>
-                                          </p:stCondLst>
-                                        </p:cTn>
-                                        <p:tgtEl>
-                                          <p:spTgt spid="17"/>
-                                        </p:tgtEl>
-                                        <p:attrNameLst>
-                                          <p:attrName>style.visibility</p:attrName>
-                                        </p:attrNameLst>
-                                      </p:cBhvr>
-                                      <p:to>
-                                        <p:strVal val="hidden"/>
-                                      </p:to>
-                                    </p:set>
-                                  </p:childTnLst>
-                                </p:cTn>
-                              </p:par>
-                              <p:par>
-                                <p:cTn id="19" presetID="10" presetClass="exit" presetSubtype="0" fill="hold" nodeType="withEffect">
-                                  <p:stCondLst>
-                                    <p:cond delay="0"/>
-                                  </p:stCondLst>
-                                  <p:childTnLst>
-                                    <p:animEffect transition="out" filter="fade">
-                                      <p:cBhvr>
-                                        <p:cTn id="20" dur="500"/>
-                                        <p:tgtEl>
-                                          <p:spTgt spid="21"/>
-                                        </p:tgtEl>
-                                      </p:cBhvr>
-                                    </p:animEffect>
-                                    <p:set>
-                                      <p:cBhvr>
-                                        <p:cTn id="21" dur="1" fill="hold">
-                                          <p:stCondLst>
-                                            <p:cond delay="499"/>
-                                          </p:stCondLst>
-                                        </p:cTn>
-                                        <p:tgtEl>
-                                          <p:spTgt spid="21"/>
-                                        </p:tgtEl>
-                                        <p:attrNameLst>
-                                          <p:attrName>style.visibility</p:attrName>
-                                        </p:attrNameLst>
-                                      </p:cBhvr>
-                                      <p:to>
-                                        <p:strVal val="hidden"/>
-                                      </p:to>
-                                    </p:set>
-                                  </p:childTnLst>
-                                </p:cTn>
-                              </p:par>
                             </p:childTnLst>
                           </p:cTn>
                         </p:par>
                         <p:par>
-                          <p:cTn id="22" fill="hold">
+                          <p:cTn id="16" fill="hold">
                             <p:stCondLst>
                               <p:cond delay="500"/>
                             </p:stCondLst>
                             <p:childTnLst>
                               <p:par>
-                                <p:cTn id="23" presetID="10" presetClass="entr" presetSubtype="0" fill="hold" grpId="0" nodeType="afterEffect">
+                                <p:cTn id="17" presetID="10" presetClass="entr" presetSubtype="0" fill="hold" grpId="0" nodeType="afterEffect">
                                   <p:stCondLst>
                                     <p:cond delay="0"/>
                                   </p:stCondLst>
                                   <p:childTnLst>
                                     <p:set>
                                       <p:cBhvr>
-                                        <p:cTn id="24" dur="1" fill="hold">
+                                        <p:cTn id="18" dur="1" fill="hold">
                                           <p:stCondLst>
                                             <p:cond delay="0"/>
                                           </p:stCondLst>
@@ -11775,7 +11438,7 @@
                                     </p:set>
                                     <p:animEffect transition="in" filter="fade">
                                       <p:cBhvr>
-                                        <p:cTn id="25" dur="500"/>
+                                        <p:cTn id="19" dur="500"/>
                                         <p:tgtEl>
                                           <p:spTgt spid="11"/>
                                         </p:tgtEl>
@@ -11785,37 +11448,37 @@
                                 </p:cTn>
                               </p:par>
                               <p:par>
-                                <p:cTn id="26" presetID="10" presetClass="entr" presetSubtype="0" fill="hold" nodeType="withEffect">
+                                <p:cTn id="20" presetID="9" presetClass="exit" presetSubtype="0" fill="hold" grpId="0" nodeType="withEffect">
                                   <p:stCondLst>
                                     <p:cond delay="0"/>
                                   </p:stCondLst>
                                   <p:childTnLst>
+                                    <p:animEffect transition="out" filter="dissolve">
+                                      <p:cBhvr>
+                                        <p:cTn id="21" dur="500"/>
+                                        <p:tgtEl>
+                                          <p:spTgt spid="3"/>
+                                        </p:tgtEl>
+                                      </p:cBhvr>
+                                    </p:animEffect>
                                     <p:set>
                                       <p:cBhvr>
-                                        <p:cTn id="27" dur="1" fill="hold">
+                                        <p:cTn id="22" dur="1" fill="hold">
                                           <p:stCondLst>
-                                            <p:cond delay="0"/>
+                                            <p:cond delay="499"/>
                                           </p:stCondLst>
                                         </p:cTn>
                                         <p:tgtEl>
-                                          <p:spTgt spid="12"/>
+                                          <p:spTgt spid="3"/>
                                         </p:tgtEl>
                                         <p:attrNameLst>
                                           <p:attrName>style.visibility</p:attrName>
                                         </p:attrNameLst>
                                       </p:cBhvr>
                                       <p:to>
-                                        <p:strVal val="visible"/>
+                                        <p:strVal val="hidden"/>
                                       </p:to>
                                     </p:set>
-                                    <p:animEffect transition="in" filter="fade">
-                                      <p:cBhvr>
-                                        <p:cTn id="28" dur="500"/>
-                                        <p:tgtEl>
-                                          <p:spTgt spid="12"/>
-                                        </p:tgtEl>
-                                      </p:cBhvr>
-                                    </p:animEffect>
                                   </p:childTnLst>
                                 </p:cTn>
                               </p:par>
@@ -11826,32 +11489,32 @@
                     </p:cTn>
                   </p:par>
                   <p:par>
-                    <p:cTn id="29" fill="hold">
+                    <p:cTn id="23" fill="hold">
                       <p:stCondLst>
                         <p:cond delay="indefinite"/>
                       </p:stCondLst>
                       <p:childTnLst>
                         <p:par>
-                          <p:cTn id="30" fill="hold">
+                          <p:cTn id="24" fill="hold">
                             <p:stCondLst>
                               <p:cond delay="0"/>
                             </p:stCondLst>
                             <p:childTnLst>
                               <p:par>
-                                <p:cTn id="31" presetID="1" presetClass="entr" presetSubtype="0" fill="hold" grpId="0" nodeType="clickEffect">
+                                <p:cTn id="25" presetID="1" presetClass="entr" presetSubtype="0" fill="hold" grpId="1" nodeType="clickEffect">
                                   <p:stCondLst>
                                     <p:cond delay="0"/>
                                   </p:stCondLst>
                                   <p:childTnLst>
                                     <p:set>
                                       <p:cBhvr>
-                                        <p:cTn id="32" dur="1" fill="hold">
+                                        <p:cTn id="26" dur="1" fill="hold">
                                           <p:stCondLst>
                                             <p:cond delay="0"/>
                                           </p:stCondLst>
                                         </p:cTn>
                                         <p:tgtEl>
-                                          <p:spTgt spid="15"/>
+                                          <p:spTgt spid="8"/>
                                         </p:tgtEl>
                                         <p:attrNameLst>
                                           <p:attrName>style.visibility</p:attrName>
@@ -11864,6 +11527,41 @@
                                   </p:childTnLst>
                                 </p:cTn>
                               </p:par>
+                              <p:par>
+                                <p:cTn id="27" presetID="3" presetClass="exit" presetSubtype="10" fill="hold" grpId="0" nodeType="withEffect">
+                                  <p:stCondLst>
+                                    <p:cond delay="0"/>
+                                  </p:stCondLst>
+                                  <p:childTnLst>
+                                    <p:animEffect transition="out" filter="blinds(horizontal)">
+                                      <p:cBhvr>
+                                        <p:cTn id="28" dur="500"/>
+                                        <p:tgtEl>
+                                          <p:spTgt spid="7"/>
+                                        </p:tgtEl>
+                                      </p:cBhvr>
+                                    </p:animEffect>
+                                    <p:set>
+                                      <p:cBhvr>
+                                        <p:cTn id="29" dur="1" fill="hold">
+                                          <p:stCondLst>
+                                            <p:cond delay="499"/>
+                                          </p:stCondLst>
+                                        </p:cTn>
+                                        <p:tgtEl>
+                                          <p:spTgt spid="7"/>
+                                        </p:tgtEl>
+                                        <p:attrNameLst>
+                                          <p:attrName>style.visibility</p:attrName>
+                                        </p:attrNameLst>
+                                      </p:cBhvr>
+                                      <p:to>
+                                        <p:strVal val="hidden"/>
+                                      </p:to>
+                                    </p:set>
+                                  </p:childTnLst>
+                                </p:cTn>
+                              </p:par>
                             </p:childTnLst>
                           </p:cTn>
                         </p:par>
@@ -11871,26 +11569,26 @@
                     </p:cTn>
                   </p:par>
                   <p:par>
-                    <p:cTn id="33" fill="hold">
+                    <p:cTn id="30" fill="hold">
                       <p:stCondLst>
                         <p:cond delay="indefinite"/>
                       </p:stCondLst>
                       <p:childTnLst>
                         <p:par>
-                          <p:cTn id="34" fill="hold">
+                          <p:cTn id="31" fill="hold">
                             <p:stCondLst>
                               <p:cond delay="0"/>
                             </p:stCondLst>
                             <p:childTnLst>
                               <p:par>
-                                <p:cTn id="35" presetID="1" presetClass="entr" presetSubtype="0" fill="hold" grpId="0" nodeType="clickEffect">
+                                <p:cTn id="32" presetID="1" presetClass="entr" presetSubtype="0" fill="hold" grpId="0" nodeType="clickEffect">
                                   <p:stCondLst>
                                     <p:cond delay="0"/>
                                   </p:stCondLst>
                                   <p:childTnLst>
                                     <p:set>
                                       <p:cBhvr>
-                                        <p:cTn id="36" dur="1" fill="hold">
+                                        <p:cTn id="33" dur="1" fill="hold">
                                           <p:stCondLst>
                                             <p:cond delay="0"/>
                                           </p:stCondLst>
@@ -11910,14 +11608,14 @@
                                 </p:cTn>
                               </p:par>
                               <p:par>
-                                <p:cTn id="37" presetID="1" presetClass="entr" presetSubtype="0" fill="hold" nodeType="withEffect">
+                                <p:cTn id="34" presetID="1" presetClass="entr" presetSubtype="0" fill="hold" nodeType="withEffect">
                                   <p:stCondLst>
                                     <p:cond delay="0"/>
                                   </p:stCondLst>
                                   <p:childTnLst>
                                     <p:set>
                                       <p:cBhvr>
-                                        <p:cTn id="38" dur="1" fill="hold">
+                                        <p:cTn id="35" dur="1" fill="hold">
                                           <p:stCondLst>
                                             <p:cond delay="0"/>
                                           </p:stCondLst>
@@ -11966,8 +11664,9 @@
     <p:bldLst>
       <p:bldP spid="11" grpId="0" animBg="1"/>
       <p:bldP spid="23" grpId="0" animBg="1"/>
-      <p:bldP spid="15" grpId="0" animBg="1"/>
-      <p:bldP spid="17" grpId="1" animBg="1"/>
+      <p:bldP spid="3" grpId="0" animBg="1"/>
+      <p:bldP spid="8" grpId="1" animBg="1"/>
+      <p:bldP spid="7" grpId="0" animBg="1"/>
     </p:bldLst>
   </p:timing>
 </p:sld>

</xml_diff>